<commit_message>
Sync Day 3-5 slides + examples + open-questions to scoped full-agent project
- Day 3 오후2 slides: rewrite to 기존/agentic 프로세스 + 생성-vs-선별 토론 + 3세션 스코프 + 팀 기획 (replaces deep-architecture theory)
- Day 4 slides: explicit 3-session scope box + corpus-based pipeline; finalize by Day 4 end
- Day 5 오전 slides: 실행·분석(3) → 버퍼/보완·발표 준비
- research_project_open_questions.md: add answer/recommendation (process critique, Q1-5, generation-vs-selection)
- examples/research-agent: corpus-based 3-session scope in README + plan template
- storyline.md synced

Co-Authored-By: Claude Opus 4.8 <noreply@anthropic.com>
</commit_message>
<xml_diff>
--- a/slides/day4.pptx
+++ b/slides/day4.pptx
@@ -4179,7 +4179,7 @@
                 <a:ea typeface="NanumSquare"/>
                 <a:cs typeface="NanumSquare"/>
               </a:rPr>
-              <a:t>구현 ② — 검증 &amp; 확장</a:t>
+              <a:t>구현 ② — 검증 &amp; 종합·보고</a:t>
             </a:r>
           </a:p>
         </p:txBody>
@@ -4548,7 +4548,7 @@
                 <a:ea typeface="NanumGothic"/>
                 <a:cs typeface="NanumGothic"/>
               </a:rPr>
-              <a:t>검증 로직 추가(출처·교차확인)</a:t>
+              <a:t>검증 로직(출처·교차확인)</a:t>
             </a:r>
           </a:p>
         </p:txBody>
@@ -4686,7 +4686,7 @@
                 <a:ea typeface="NanumGothic"/>
                 <a:cs typeface="NanumGothic"/>
               </a:rPr>
-              <a:t>병렬/다중 검색</a:t>
+              <a:t>종합 → 인용 보고서 생성</a:t>
             </a:r>
           </a:p>
         </p:txBody>
@@ -4824,7 +4824,7 @@
                 <a:ea typeface="NanumGothic"/>
                 <a:cs typeface="NanumGothic"/>
               </a:rPr>
-              <a:t>종합 품질 개선</a:t>
+              <a:t>상충·불확실성 표기</a:t>
             </a:r>
           </a:p>
         </p:txBody>
@@ -5100,7 +5100,7 @@
                 <a:ea typeface="NanumGothic"/>
                 <a:cs typeface="NanumGothic"/>
               </a:rPr>
-              <a:t>검증·확장된 리서치 에이전트 v1
+              <a:t>검증·인용 보고서까지 되는 에이전트 v1
 (구성도 placeholder)</a:t>
             </a:r>
           </a:p>
@@ -14616,7 +14616,7 @@
                 <a:ea typeface="NanumSquare"/>
                 <a:cs typeface="NanumSquare"/>
               </a:rPr>
-              <a:t>재실행 &amp; 결과 분석 실습</a:t>
+              <a:t>재실행 &amp; 결과 분석 → 최종 확정</a:t>
             </a:r>
           </a:p>
         </p:txBody>
@@ -14985,7 +14985,7 @@
                 <a:ea typeface="NanumGothic"/>
                 <a:cs typeface="NanumGothic"/>
               </a:rPr>
-              <a:t>개선 항목 반영</a:t>
+              <a:t>개선 항목 반영·재실행</a:t>
             </a:r>
           </a:p>
         </p:txBody>
@@ -15123,7 +15123,7 @@
                 <a:ea typeface="NanumGothic"/>
                 <a:cs typeface="NanumGothic"/>
               </a:rPr>
-              <a:t>재실행 &amp; 비교</a:t>
+              <a:t>강점/약점·한계 표 정리</a:t>
             </a:r>
           </a:p>
         </p:txBody>
@@ -15261,7 +15261,7 @@
                 <a:ea typeface="NanumGothic"/>
                 <a:cs typeface="NanumGothic"/>
               </a:rPr>
-              <a:t>강점/약점 표 정리</a:t>
+              <a:t>발표 후보 결과 선별</a:t>
             </a:r>
           </a:p>
         </p:txBody>
@@ -15399,7 +15399,7 @@
                 <a:ea typeface="NanumGothic"/>
                 <a:cs typeface="NanumGothic"/>
               </a:rPr>
-              <a:t>개선 항목 도출</a:t>
+              <a:t>최종 결과 확정</a:t>
             </a:r>
           </a:p>
         </p:txBody>
@@ -15537,8 +15537,8 @@
                 <a:ea typeface="NanumGothic"/>
                 <a:cs typeface="NanumGothic"/>
               </a:rPr>
-              <a:t>결과 분석 노트(강점·약점·개선점)
-(placeholder)</a:t>
+              <a:t>최종 결과물 + 분석 노트(강점·약점·개선점)
+에이전트 완주! (placeholder)</a:t>
             </a:r>
           </a:p>
         </p:txBody>
@@ -16014,7 +16014,7 @@
                 <a:ea typeface="NanumGothic"/>
                 <a:cs typeface="NanumGothic"/>
               </a:rPr>
-              <a:t>팀 설계를 MVP → 검증·확장 순으로 구현한다</a:t>
+              <a:t>팀 에이전트를 MVP → 검증·종합(인용 보고서) 순으로 3세션 안에 완주</a:t>
             </a:r>
           </a:p>
         </p:txBody>
@@ -18778,7 +18778,7 @@
                 <a:ea typeface="NanumGothic"/>
                 <a:cs typeface="NanumGothic"/>
               </a:rPr>
-              <a:t>팀 에이전트 설계 정리</a:t>
+              <a:t>3세션 스코프 — 무엇을 만드나</a:t>
             </a:r>
           </a:p>
         </p:txBody>
@@ -18962,7 +18962,7 @@
                 <a:ea typeface="NanumGothic"/>
                 <a:cs typeface="NanumGothic"/>
               </a:rPr>
-              <a:t>구현 단계 개요</a:t>
+              <a:t>팀 에이전트 설계 정리</a:t>
             </a:r>
           </a:p>
         </p:txBody>
@@ -19330,7 +19330,7 @@
                 <a:ea typeface="NanumGothic"/>
                 <a:cs typeface="NanumGothic"/>
               </a:rPr>
-              <a:t>기본 흐름·검색 연결(실습)</a:t>
+              <a:t>구현① 기본 흐름·검색(corpus)</a:t>
             </a:r>
           </a:p>
         </p:txBody>
@@ -19514,7 +19514,7 @@
                 <a:ea typeface="NanumGothic"/>
                 <a:cs typeface="NanumGothic"/>
               </a:rPr>
-              <a:t>검증·확장(실습)</a:t>
+              <a:t>구현② 검증·종합·보고</a:t>
             </a:r>
           </a:p>
         </p:txBody>
@@ -19667,7 +19667,7 @@
                 <a:ea typeface="NanumGothic"/>
                 <a:cs typeface="NanumGothic"/>
               </a:rPr>
-              <a:t>기획</a:t>
+              <a:t>스코프</a:t>
             </a:r>
           </a:p>
         </p:txBody>
@@ -19714,7 +19714,7 @@
                 <a:ea typeface="NanumSquare"/>
                 <a:cs typeface="NanumSquare"/>
               </a:rPr>
-              <a:t>팀 에이전트 설계 정리</a:t>
+              <a:t>3세션 안에 만들 것</a:t>
             </a:r>
           </a:p>
         </p:txBody>
@@ -19943,7 +19943,7 @@
                 <a:ea typeface="NanumGothic"/>
                 <a:cs typeface="NanumGothic"/>
               </a:rPr>
-              <a:t>주제·핵심 질문 재확인</a:t>
+              <a:t>파이프라인</a:t>
             </a:r>
           </a:p>
         </p:txBody>
@@ -19990,7 +19990,7 @@
                 <a:ea typeface="NanumGothic"/>
                 <a:cs typeface="NanumGothic"/>
               </a:rPr>
-              <a:t>Day 3 기획서 기반</a:t>
+              <a:t>질문 → 검색(로컬 corpus) → 검증 → 종합 → 인용 보고서</a:t>
             </a:r>
           </a:p>
         </p:txBody>
@@ -20081,7 +20081,7 @@
                 <a:ea typeface="NanumGothic"/>
                 <a:cs typeface="NanumGothic"/>
               </a:rPr>
-              <a:t>필요한 데이터 소스·도구</a:t>
+              <a:t>스코프 제한</a:t>
             </a:r>
           </a:p>
         </p:txBody>
@@ -20128,7 +20128,7 @@
                 <a:ea typeface="NanumGothic"/>
                 <a:cs typeface="NanumGothic"/>
               </a:rPr>
-              <a:t>어디서 검색하나</a:t>
+              <a:t>corpus 기반 — 오픈 웹 크롤링·벡터DB 불필요</a:t>
             </a:r>
           </a:p>
         </p:txBody>
@@ -20219,7 +20219,7 @@
                 <a:ea typeface="NanumGothic"/>
                 <a:cs typeface="NanumGothic"/>
               </a:rPr>
-              <a:t>산출물 형태</a:t>
+              <a:t>완주 기준</a:t>
             </a:r>
           </a:p>
         </p:txBody>
@@ -20266,7 +20266,111 @@
                 <a:ea typeface="NanumGothic"/>
                 <a:cs typeface="NanumGothic"/>
               </a:rPr>
-              <a:t>보고서/요약 (placeholder)</a:t>
+              <a:t>Day 4 끝 = 핵심 질문에 답하는 1~2장 인용 보고서</a:t>
+            </a:r>
+          </a:p>
+        </p:txBody>
+      </p:sp>
+      <p:sp>
+        <p:nvSpPr>
+          <p:cNvPr id="18" name="Rounded Rectangle 17"/>
+          <p:cNvSpPr/>
+          <p:nvPr/>
+        </p:nvSpPr>
+        <p:spPr>
+          <a:xfrm>
+            <a:off x="502920" y="5532120"/>
+            <a:ext cx="11155680" cy="658368"/>
+          </a:xfrm>
+          <a:prstGeom prst="roundRect">
+            <a:avLst/>
+          </a:prstGeom>
+          <a:solidFill>
+            <a:srgbClr val="F1F5F9"/>
+          </a:solidFill>
+          <a:ln w="12700">
+            <a:solidFill>
+              <a:srgbClr val="E2E8F0"/>
+            </a:solidFill>
+          </a:ln>
+          <a:effectLst/>
+        </p:spPr>
+        <p:style>
+          <a:lnRef idx="1">
+            <a:schemeClr val="accent1"/>
+          </a:lnRef>
+          <a:fillRef idx="3">
+            <a:schemeClr val="accent1"/>
+          </a:fillRef>
+          <a:effectRef idx="2">
+            <a:schemeClr val="accent1"/>
+          </a:effectRef>
+          <a:fontRef idx="minor">
+            <a:schemeClr val="lt1"/>
+          </a:fontRef>
+        </p:style>
+        <p:txBody>
+          <a:bodyPr rtlCol="0" anchor="ctr"/>
+          <a:lstStyle/>
+          <a:p>
+            <a:pPr algn="ctr"/>
+          </a:p>
+        </p:txBody>
+      </p:sp>
+      <p:sp>
+        <p:nvSpPr>
+          <p:cNvPr id="19" name="TextBox 18"/>
+          <p:cNvSpPr txBox="1"/>
+          <p:nvPr/>
+        </p:nvSpPr>
+        <p:spPr>
+          <a:xfrm>
+            <a:off x="777240" y="5532120"/>
+            <a:ext cx="10607040" cy="658368"/>
+          </a:xfrm>
+          <a:prstGeom prst="rect">
+            <a:avLst/>
+          </a:prstGeom>
+          <a:noFill/>
+        </p:spPr>
+        <p:txBody>
+          <a:bodyPr wrap="square" anchor="ctr" lIns="0" rIns="0" tIns="0" bIns="0">
+            <a:spAutoFit/>
+          </a:bodyPr>
+          <a:lstStyle/>
+          <a:p>
+            <a:pPr algn="l">
+              <a:lnSpc>
+                <a:spcPct val="100000"/>
+              </a:lnSpc>
+              <a:spcBef>
+                <a:spcPts val="0"/>
+              </a:spcBef>
+              <a:spcAft>
+                <a:spcPts val="600"/>
+              </a:spcAft>
+            </a:pPr>
+            <a:r>
+              <a:rPr sz="1200" b="1">
+                <a:solidFill>
+                  <a:srgbClr val="F59E0B"/>
+                </a:solidFill>
+                <a:latin typeface="NanumGothic"/>
+                <a:ea typeface="NanumGothic"/>
+                <a:cs typeface="NanumGothic"/>
+              </a:rPr>
+              <a:t>NOTE   </a:t>
+            </a:r>
+            <a:r>
+              <a:rPr sz="1300" b="0">
+                <a:solidFill>
+                  <a:srgbClr val="0F172A"/>
+                </a:solidFill>
+                <a:latin typeface="NanumGothic"/>
+                <a:ea typeface="NanumGothic"/>
+                <a:cs typeface="NanumGothic"/>
+              </a:rPr>
+              <a:t>작게 만들고 키운다 — 욕심내지 말 것</a:t>
             </a:r>
           </a:p>
         </p:txBody>
@@ -20419,7 +20523,7 @@
                 <a:ea typeface="NanumGothic"/>
                 <a:cs typeface="NanumGothic"/>
               </a:rPr>
-              <a:t>학습 목표</a:t>
+              <a:t>기획</a:t>
             </a:r>
           </a:p>
         </p:txBody>
@@ -20466,7 +20570,7 @@
                 <a:ea typeface="NanumSquare"/>
                 <a:cs typeface="NanumSquare"/>
               </a:rPr>
-              <a:t>구현 단계에서 할 일</a:t>
+              <a:t>팀 에이전트 설계 정리</a:t>
             </a:r>
           </a:p>
         </p:txBody>
@@ -20695,7 +20799,7 @@
                 <a:ea typeface="NanumGothic"/>
                 <a:cs typeface="NanumGothic"/>
               </a:rPr>
-              <a:t>검색·검증·종합 흐름 구성</a:t>
+              <a:t>주제·핵심 질문 재확인</a:t>
             </a:r>
           </a:p>
         </p:txBody>
@@ -20742,7 +20846,7 @@
                 <a:ea typeface="NanumGothic"/>
                 <a:cs typeface="NanumGothic"/>
               </a:rPr>
-              <a:t>Day 3 아키텍처를 코드로</a:t>
+              <a:t>Day 3 기획서 기반</a:t>
             </a:r>
           </a:p>
         </p:txBody>
@@ -20833,7 +20937,7 @@
                 <a:ea typeface="NanumGothic"/>
                 <a:cs typeface="NanumGothic"/>
               </a:rPr>
-              <a:t>도구·MCP 연결</a:t>
+              <a:t>corpus 확인</a:t>
             </a:r>
           </a:p>
         </p:txBody>
@@ -20880,7 +20984,7 @@
                 <a:ea typeface="NanumGothic"/>
                 <a:cs typeface="NanumGothic"/>
               </a:rPr>
-              <a:t>데이터 소스 붙이기</a:t>
+              <a:t>어떤 문서 폴더에서 검색하나</a:t>
             </a:r>
           </a:p>
         </p:txBody>
@@ -20971,7 +21075,7 @@
                 <a:ea typeface="NanumGothic"/>
                 <a:cs typeface="NanumGothic"/>
               </a:rPr>
-              <a:t>작게 시작해 확장</a:t>
+              <a:t>산출물 형태</a:t>
             </a:r>
           </a:p>
         </p:txBody>
@@ -21018,7 +21122,7 @@
                 <a:ea typeface="NanumGothic"/>
                 <a:cs typeface="NanumGothic"/>
               </a:rPr>
-              <a:t>최소 기능부터</a:t>
+              <a:t>인용 보고서 구조 합의</a:t>
             </a:r>
           </a:p>
         </p:txBody>
@@ -21494,7 +21598,7 @@
                 <a:ea typeface="NanumGothic"/>
                 <a:cs typeface="NanumGothic"/>
               </a:rPr>
-              <a:t>질문→검색→요약</a:t>
+              <a:t>질문 → 검색 → 요약</a:t>
             </a:r>
           </a:p>
         </p:txBody>
@@ -21632,7 +21736,7 @@
                 <a:ea typeface="NanumGothic"/>
                 <a:cs typeface="NanumGothic"/>
               </a:rPr>
-              <a:t>검증·병렬화 추가</a:t>
+              <a:t>검증·인용 추가</a:t>
             </a:r>
           </a:p>
         </p:txBody>
@@ -21970,7 +22074,7 @@
                 <a:ea typeface="NanumSquare"/>
                 <a:cs typeface="NanumSquare"/>
               </a:rPr>
-              <a:t>구현 ① — 기본 흐름 &amp; 검색 연결</a:t>
+              <a:t>구현 ① — 기본 흐름 &amp; 검색(로컬 corpus)</a:t>
             </a:r>
           </a:p>
         </p:txBody>
@@ -22339,7 +22443,7 @@
                 <a:ea typeface="NanumGothic"/>
                 <a:cs typeface="NanumGothic"/>
               </a:rPr>
-              <a:t>기본 흐름 구성(질문→검색→요약)</a:t>
+              <a:t>기본 흐름(질문→검색→요약)</a:t>
             </a:r>
           </a:p>
         </p:txBody>
@@ -22477,7 +22581,7 @@
                 <a:ea typeface="NanumGothic"/>
                 <a:cs typeface="NanumGothic"/>
               </a:rPr>
-              <a:t>검색/도구 연결</a:t>
+              <a:t>corpus 폴더 검색 연결</a:t>
             </a:r>
           </a:p>
         </p:txBody>

</xml_diff>

<commit_message>
Incorporate MOOSE-Chem as conceptual blueprint for hypothesis generation
- Day 4 오후2 slide: '가설 생성 방법론 — MOOSE-Chem 청사진' (영감검색→조합→순위, cited)
- Reframe generation to two paths: gap 기반 + 조합(영감) 기반 (twocol) + 생성 원칙
- examples: research-prompts (3b 조합 생성기), CLAUDE.md (두 갈래)
- research_project_open_questions.md: 참고문헌 (MOOSE-Chem ICLR'25, MOOSE ACL'24, MOOSE-Chem2)
- timetable 오후2: blueprint in 가설 생성 lecture intro

Co-Authored-By: Claude Opus 4.8 <noreply@anthropic.com>
</commit_message>
<xml_diff>
--- a/slides/day4.pptx
+++ b/slides/day4.pptx
@@ -29,6 +29,8 @@
     <p:sldId id="277" r:id="rId28"/>
     <p:sldId id="278" r:id="rId29"/>
     <p:sldId id="279" r:id="rId30"/>
+    <p:sldId id="280" r:id="rId31"/>
+    <p:sldId id="281" r:id="rId32"/>
   </p:sldIdLst>
   <p:sldSz cx="12191695" cy="6858000" type="screen4x3"/>
   <p:notesSz cx="6858000" cy="9144000"/>
@@ -10672,7 +10674,7 @@
                 <a:ea typeface="NanumGothic"/>
                 <a:cs typeface="NanumGothic"/>
               </a:rPr>
-              <a:t>90분 · 4 파트</a:t>
+              <a:t>90분 · 5 파트</a:t>
             </a:r>
           </a:p>
         </p:txBody>
@@ -11087,7 +11089,7 @@
                 <a:ea typeface="NanumGothic"/>
                 <a:cs typeface="NanumGothic"/>
               </a:rPr>
-              <a:t>가설 생성 (다수)</a:t>
+              <a:t>방법론 — MOOSE-Chem 청사진</a:t>
             </a:r>
           </a:p>
         </p:txBody>
@@ -11271,7 +11273,7 @@
                 <a:ea typeface="NanumGothic"/>
                 <a:cs typeface="NanumGothic"/>
               </a:rPr>
-              <a:t>평가·우선순위 (생성 vs 선별)</a:t>
+              <a:t>가설 생성 (gap + 조합)</a:t>
             </a:r>
           </a:p>
         </p:txBody>
@@ -11422,6 +11424,190 @@
         <p:spPr>
           <a:xfrm>
             <a:off x="1216152" y="4288536"/>
+            <a:ext cx="10287000" cy="603504"/>
+          </a:xfrm>
+          <a:prstGeom prst="rect">
+            <a:avLst/>
+          </a:prstGeom>
+          <a:noFill/>
+        </p:spPr>
+        <p:txBody>
+          <a:bodyPr wrap="square" anchor="ctr" lIns="0" rIns="0" tIns="0" bIns="0">
+            <a:spAutoFit/>
+          </a:bodyPr>
+          <a:lstStyle/>
+          <a:p>
+            <a:pPr algn="l">
+              <a:lnSpc>
+                <a:spcPct val="100000"/>
+              </a:lnSpc>
+              <a:spcBef>
+                <a:spcPts val="0"/>
+              </a:spcBef>
+              <a:spcAft>
+                <a:spcPts val="600"/>
+              </a:spcAft>
+            </a:pPr>
+            <a:r>
+              <a:rPr sz="1400" b="1">
+                <a:solidFill>
+                  <a:srgbClr val="0F172A"/>
+                </a:solidFill>
+                <a:latin typeface="NanumGothic"/>
+                <a:ea typeface="NanumGothic"/>
+                <a:cs typeface="NanumGothic"/>
+              </a:rPr>
+              <a:t>평가·우선순위 (생성 vs 선별)</a:t>
+            </a:r>
+          </a:p>
+        </p:txBody>
+      </p:sp>
+      <p:sp>
+        <p:nvSpPr>
+          <p:cNvPr id="28" name="Rounded Rectangle 27"/>
+          <p:cNvSpPr/>
+          <p:nvPr/>
+        </p:nvSpPr>
+        <p:spPr>
+          <a:xfrm>
+            <a:off x="502920" y="5001768"/>
+            <a:ext cx="11155680" cy="603504"/>
+          </a:xfrm>
+          <a:prstGeom prst="roundRect">
+            <a:avLst/>
+          </a:prstGeom>
+          <a:solidFill>
+            <a:srgbClr val="F8FAFC"/>
+          </a:solidFill>
+          <a:ln w="12700">
+            <a:solidFill>
+              <a:srgbClr val="E2E8F0"/>
+            </a:solidFill>
+          </a:ln>
+          <a:effectLst/>
+        </p:spPr>
+        <p:style>
+          <a:lnRef idx="1">
+            <a:schemeClr val="accent1"/>
+          </a:lnRef>
+          <a:fillRef idx="3">
+            <a:schemeClr val="accent1"/>
+          </a:fillRef>
+          <a:effectRef idx="2">
+            <a:schemeClr val="accent1"/>
+          </a:effectRef>
+          <a:fontRef idx="minor">
+            <a:schemeClr val="lt1"/>
+          </a:fontRef>
+        </p:style>
+        <p:txBody>
+          <a:bodyPr rtlCol="0" anchor="ctr"/>
+          <a:lstStyle/>
+          <a:p>
+            <a:pPr algn="ctr"/>
+          </a:p>
+        </p:txBody>
+      </p:sp>
+      <p:sp>
+        <p:nvSpPr>
+          <p:cNvPr id="29" name="Oval 28"/>
+          <p:cNvSpPr/>
+          <p:nvPr/>
+        </p:nvSpPr>
+        <p:spPr>
+          <a:xfrm>
+            <a:off x="649224" y="5120640"/>
+            <a:ext cx="384048" cy="384048"/>
+          </a:xfrm>
+          <a:prstGeom prst="ellipse">
+            <a:avLst/>
+          </a:prstGeom>
+          <a:solidFill>
+            <a:srgbClr val="F59E0B"/>
+          </a:solidFill>
+          <a:ln>
+            <a:noFill/>
+          </a:ln>
+          <a:effectLst/>
+        </p:spPr>
+        <p:style>
+          <a:lnRef idx="1">
+            <a:schemeClr val="accent1"/>
+          </a:lnRef>
+          <a:fillRef idx="3">
+            <a:schemeClr val="accent1"/>
+          </a:fillRef>
+          <a:effectRef idx="2">
+            <a:schemeClr val="accent1"/>
+          </a:effectRef>
+          <a:fontRef idx="minor">
+            <a:schemeClr val="lt1"/>
+          </a:fontRef>
+        </p:style>
+        <p:txBody>
+          <a:bodyPr rtlCol="0" anchor="ctr"/>
+          <a:lstStyle/>
+          <a:p>
+            <a:pPr algn="ctr"/>
+          </a:p>
+        </p:txBody>
+      </p:sp>
+      <p:sp>
+        <p:nvSpPr>
+          <p:cNvPr id="30" name="TextBox 29"/>
+          <p:cNvSpPr txBox="1"/>
+          <p:nvPr/>
+        </p:nvSpPr>
+        <p:spPr>
+          <a:xfrm>
+            <a:off x="649224" y="5120640"/>
+            <a:ext cx="384048" cy="384048"/>
+          </a:xfrm>
+          <a:prstGeom prst="rect">
+            <a:avLst/>
+          </a:prstGeom>
+          <a:noFill/>
+        </p:spPr>
+        <p:txBody>
+          <a:bodyPr wrap="square" anchor="ctr" lIns="0" rIns="0" tIns="0" bIns="0">
+            <a:spAutoFit/>
+          </a:bodyPr>
+          <a:lstStyle/>
+          <a:p>
+            <a:pPr algn="ctr">
+              <a:lnSpc>
+                <a:spcPct val="100000"/>
+              </a:lnSpc>
+              <a:spcBef>
+                <a:spcPts val="0"/>
+              </a:spcBef>
+              <a:spcAft>
+                <a:spcPts val="600"/>
+              </a:spcAft>
+            </a:pPr>
+            <a:r>
+              <a:rPr sz="1300" b="1">
+                <a:solidFill>
+                  <a:srgbClr val="FFFFFF"/>
+                </a:solidFill>
+                <a:latin typeface="NanumSquare"/>
+                <a:ea typeface="NanumSquare"/>
+                <a:cs typeface="NanumSquare"/>
+              </a:rPr>
+              <a:t>5</a:t>
+            </a:r>
+          </a:p>
+        </p:txBody>
+      </p:sp>
+      <p:sp>
+        <p:nvSpPr>
+          <p:cNvPr id="31" name="TextBox 30"/>
+          <p:cNvSpPr txBox="1"/>
+          <p:nvPr/>
+        </p:nvSpPr>
+        <p:spPr>
+          <a:xfrm>
+            <a:off x="1216152" y="5001768"/>
             <a:ext cx="10287000" cy="603504"/>
           </a:xfrm>
           <a:prstGeom prst="rect">
@@ -13725,7 +13911,7 @@
                 <a:ea typeface="NanumGothic"/>
                 <a:cs typeface="NanumGothic"/>
               </a:rPr>
-              <a:t>가설 생성</a:t>
+              <a:t>방법론</a:t>
             </a:r>
           </a:p>
         </p:txBody>
@@ -13772,7 +13958,7 @@
                 <a:ea typeface="NanumSquare"/>
                 <a:cs typeface="NanumSquare"/>
               </a:rPr>
-              <a:t>gap에서 가설 다수 만들기</a:t>
+              <a:t>가설 생성 방법론 — MOOSE-Chem 청사진</a:t>
             </a:r>
           </a:p>
         </p:txBody>
@@ -13917,16 +14103,62 @@
       </p:sp>
       <p:sp>
         <p:nvSpPr>
-          <p:cNvPr id="9" name="Oval 8"/>
+          <p:cNvPr id="9" name="Rounded Rectangle 8"/>
           <p:cNvSpPr/>
           <p:nvPr/>
         </p:nvSpPr>
         <p:spPr>
           <a:xfrm>
-            <a:off x="548640" y="1911096"/>
-            <a:ext cx="146304" cy="146304"/>
-          </a:xfrm>
-          <a:prstGeom prst="ellipse">
+            <a:off x="502920" y="2651760"/>
+            <a:ext cx="3505200" cy="1737360"/>
+          </a:xfrm>
+          <a:prstGeom prst="roundRect">
+            <a:avLst/>
+          </a:prstGeom>
+          <a:solidFill>
+            <a:srgbClr val="F8FAFC"/>
+          </a:solidFill>
+          <a:ln w="12700">
+            <a:solidFill>
+              <a:srgbClr val="E2E8F0"/>
+            </a:solidFill>
+          </a:ln>
+          <a:effectLst/>
+        </p:spPr>
+        <p:style>
+          <a:lnRef idx="1">
+            <a:schemeClr val="accent1"/>
+          </a:lnRef>
+          <a:fillRef idx="3">
+            <a:schemeClr val="accent1"/>
+          </a:fillRef>
+          <a:effectRef idx="2">
+            <a:schemeClr val="accent1"/>
+          </a:effectRef>
+          <a:fontRef idx="minor">
+            <a:schemeClr val="lt1"/>
+          </a:fontRef>
+        </p:style>
+        <p:txBody>
+          <a:bodyPr rtlCol="0" anchor="ctr"/>
+          <a:lstStyle/>
+          <a:p>
+            <a:pPr algn="ctr"/>
+          </a:p>
+        </p:txBody>
+      </p:sp>
+      <p:sp>
+        <p:nvSpPr>
+          <p:cNvPr id="10" name="Rectangle 9"/>
+          <p:cNvSpPr/>
+          <p:nvPr/>
+        </p:nvSpPr>
+        <p:spPr>
+          <a:xfrm>
+            <a:off x="502920" y="2651760"/>
+            <a:ext cx="3505200" cy="109728"/>
+          </a:xfrm>
+          <a:prstGeom prst="rect">
             <a:avLst/>
           </a:prstGeom>
           <a:solidFill>
@@ -13961,14 +14193,14 @@
       </p:sp>
       <p:sp>
         <p:nvSpPr>
-          <p:cNvPr id="10" name="TextBox 9"/>
-          <p:cNvSpPr txBox="1"/>
-          <p:nvPr/>
-        </p:nvSpPr>
-        <p:spPr>
-          <a:xfrm>
-            <a:off x="868680" y="1828800"/>
-            <a:ext cx="10607040" cy="457200"/>
+          <p:cNvPr id="11" name="TextBox 10"/>
+          <p:cNvSpPr txBox="1"/>
+          <p:nvPr/>
+        </p:nvSpPr>
+        <p:spPr>
+          <a:xfrm>
+            <a:off x="640080" y="2944368"/>
+            <a:ext cx="3230880" cy="365760"/>
           </a:xfrm>
           <a:prstGeom prst="rect">
             <a:avLst/>
@@ -13993,7 +14225,54 @@
               </a:spcAft>
             </a:pPr>
             <a:r>
-              <a:rPr sz="1600" b="1">
+              <a:rPr sz="1300" b="1">
+                <a:solidFill>
+                  <a:srgbClr val="F59E0B"/>
+                </a:solidFill>
+                <a:latin typeface="NanumSquare"/>
+                <a:ea typeface="NanumSquare"/>
+                <a:cs typeface="NanumSquare"/>
+              </a:rPr>
+              <a:t>1</a:t>
+            </a:r>
+          </a:p>
+        </p:txBody>
+      </p:sp>
+      <p:sp>
+        <p:nvSpPr>
+          <p:cNvPr id="12" name="TextBox 11"/>
+          <p:cNvSpPr txBox="1"/>
+          <p:nvPr/>
+        </p:nvSpPr>
+        <p:spPr>
+          <a:xfrm>
+            <a:off x="640080" y="3310128"/>
+            <a:ext cx="3230880" cy="548640"/>
+          </a:xfrm>
+          <a:prstGeom prst="rect">
+            <a:avLst/>
+          </a:prstGeom>
+          <a:noFill/>
+        </p:spPr>
+        <p:txBody>
+          <a:bodyPr wrap="square" anchor="t" lIns="0" rIns="0" tIns="0" bIns="0">
+            <a:spAutoFit/>
+          </a:bodyPr>
+          <a:lstStyle/>
+          <a:p>
+            <a:pPr algn="l">
+              <a:lnSpc>
+                <a:spcPct val="100000"/>
+              </a:lnSpc>
+              <a:spcBef>
+                <a:spcPts val="0"/>
+              </a:spcBef>
+              <a:spcAft>
+                <a:spcPts val="600"/>
+              </a:spcAft>
+            </a:pPr>
+            <a:r>
+              <a:rPr sz="1500" b="1">
                 <a:solidFill>
                   <a:srgbClr val="0F172A"/>
                 </a:solidFill>
@@ -14001,21 +14280,21 @@
                 <a:ea typeface="NanumGothic"/>
                 <a:cs typeface="NanumGothic"/>
               </a:rPr>
-              <a:t>각 gap에서 여러 개</a:t>
-            </a:r>
-          </a:p>
-        </p:txBody>
-      </p:sp>
-      <p:sp>
-        <p:nvSpPr>
-          <p:cNvPr id="11" name="TextBox 10"/>
-          <p:cNvSpPr txBox="1"/>
-          <p:nvPr/>
-        </p:nvSpPr>
-        <p:spPr>
-          <a:xfrm>
-            <a:off x="868680" y="2212848"/>
-            <a:ext cx="10607040" cy="457200"/>
+              <a:t>영감 검색</a:t>
+            </a:r>
+          </a:p>
+        </p:txBody>
+      </p:sp>
+      <p:sp>
+        <p:nvSpPr>
+          <p:cNvPr id="13" name="TextBox 12"/>
+          <p:cNvSpPr txBox="1"/>
+          <p:nvPr/>
+        </p:nvSpPr>
+        <p:spPr>
+          <a:xfrm>
+            <a:off x="640080" y="3822192"/>
+            <a:ext cx="3230880" cy="457200"/>
           </a:xfrm>
           <a:prstGeom prst="rect">
             <a:avLst/>
@@ -14040,7 +14319,7 @@
               </a:spcAft>
             </a:pPr>
             <a:r>
-              <a:rPr sz="1300" b="0">
+              <a:rPr sz="1100" b="0">
                 <a:solidFill>
                   <a:srgbClr val="64748B"/>
                 </a:solidFill>
@@ -14048,23 +14327,116 @@
                 <a:ea typeface="NanumGothic"/>
                 <a:cs typeface="NanumGothic"/>
               </a:rPr>
-              <a:t>하나가 아니라 6~10개 — breadth</a:t>
-            </a:r>
-          </a:p>
-        </p:txBody>
-      </p:sp>
-      <p:sp>
-        <p:nvSpPr>
-          <p:cNvPr id="12" name="Oval 11"/>
+              <a:t>논문에서 아이디어</a:t>
+            </a:r>
+          </a:p>
+        </p:txBody>
+      </p:sp>
+      <p:sp>
+        <p:nvSpPr>
+          <p:cNvPr id="14" name="TextBox 13"/>
+          <p:cNvSpPr txBox="1"/>
+          <p:nvPr/>
+        </p:nvSpPr>
+        <p:spPr>
+          <a:xfrm>
+            <a:off x="4053840" y="3154680"/>
+            <a:ext cx="274320" cy="548640"/>
+          </a:xfrm>
+          <a:prstGeom prst="rect">
+            <a:avLst/>
+          </a:prstGeom>
+          <a:noFill/>
+        </p:spPr>
+        <p:txBody>
+          <a:bodyPr wrap="square" anchor="ctr" lIns="0" rIns="0" tIns="0" bIns="0">
+            <a:spAutoFit/>
+          </a:bodyPr>
+          <a:lstStyle/>
+          <a:p>
+            <a:pPr algn="ctr">
+              <a:lnSpc>
+                <a:spcPct val="100000"/>
+              </a:lnSpc>
+              <a:spcBef>
+                <a:spcPts val="0"/>
+              </a:spcBef>
+              <a:spcAft>
+                <a:spcPts val="600"/>
+              </a:spcAft>
+            </a:pPr>
+            <a:r>
+              <a:rPr sz="2200" b="1">
+                <a:solidFill>
+                  <a:srgbClr val="F59E0B"/>
+                </a:solidFill>
+                <a:latin typeface="NanumSquare"/>
+                <a:ea typeface="NanumSquare"/>
+                <a:cs typeface="NanumSquare"/>
+              </a:rPr>
+              <a:t>→</a:t>
+            </a:r>
+          </a:p>
+        </p:txBody>
+      </p:sp>
+      <p:sp>
+        <p:nvSpPr>
+          <p:cNvPr id="15" name="Rounded Rectangle 14"/>
           <p:cNvSpPr/>
           <p:nvPr/>
         </p:nvSpPr>
         <p:spPr>
           <a:xfrm>
-            <a:off x="548640" y="2779776"/>
-            <a:ext cx="146304" cy="146304"/>
-          </a:xfrm>
-          <a:prstGeom prst="ellipse">
+            <a:off x="4328160" y="2651760"/>
+            <a:ext cx="3505200" cy="1737360"/>
+          </a:xfrm>
+          <a:prstGeom prst="roundRect">
+            <a:avLst/>
+          </a:prstGeom>
+          <a:solidFill>
+            <a:srgbClr val="F8FAFC"/>
+          </a:solidFill>
+          <a:ln w="12700">
+            <a:solidFill>
+              <a:srgbClr val="E2E8F0"/>
+            </a:solidFill>
+          </a:ln>
+          <a:effectLst/>
+        </p:spPr>
+        <p:style>
+          <a:lnRef idx="1">
+            <a:schemeClr val="accent1"/>
+          </a:lnRef>
+          <a:fillRef idx="3">
+            <a:schemeClr val="accent1"/>
+          </a:fillRef>
+          <a:effectRef idx="2">
+            <a:schemeClr val="accent1"/>
+          </a:effectRef>
+          <a:fontRef idx="minor">
+            <a:schemeClr val="lt1"/>
+          </a:fontRef>
+        </p:style>
+        <p:txBody>
+          <a:bodyPr rtlCol="0" anchor="ctr"/>
+          <a:lstStyle/>
+          <a:p>
+            <a:pPr algn="ctr"/>
+          </a:p>
+        </p:txBody>
+      </p:sp>
+      <p:sp>
+        <p:nvSpPr>
+          <p:cNvPr id="16" name="Rectangle 15"/>
+          <p:cNvSpPr/>
+          <p:nvPr/>
+        </p:nvSpPr>
+        <p:spPr>
+          <a:xfrm>
+            <a:off x="4328160" y="2651760"/>
+            <a:ext cx="3505200" cy="109728"/>
+          </a:xfrm>
+          <a:prstGeom prst="rect">
             <a:avLst/>
           </a:prstGeom>
           <a:solidFill>
@@ -14099,14 +14471,14 @@
       </p:sp>
       <p:sp>
         <p:nvSpPr>
-          <p:cNvPr id="13" name="TextBox 12"/>
-          <p:cNvSpPr txBox="1"/>
-          <p:nvPr/>
-        </p:nvSpPr>
-        <p:spPr>
-          <a:xfrm>
-            <a:off x="868680" y="2697480"/>
-            <a:ext cx="10607040" cy="457200"/>
+          <p:cNvPr id="17" name="TextBox 16"/>
+          <p:cNvSpPr txBox="1"/>
+          <p:nvPr/>
+        </p:nvSpPr>
+        <p:spPr>
+          <a:xfrm>
+            <a:off x="4465320" y="2944368"/>
+            <a:ext cx="3230880" cy="365760"/>
           </a:xfrm>
           <a:prstGeom prst="rect">
             <a:avLst/>
@@ -14131,7 +14503,54 @@
               </a:spcAft>
             </a:pPr>
             <a:r>
-              <a:rPr sz="1600" b="1">
+              <a:rPr sz="1300" b="1">
+                <a:solidFill>
+                  <a:srgbClr val="F59E0B"/>
+                </a:solidFill>
+                <a:latin typeface="NanumSquare"/>
+                <a:ea typeface="NanumSquare"/>
+                <a:cs typeface="NanumSquare"/>
+              </a:rPr>
+              <a:t>2</a:t>
+            </a:r>
+          </a:p>
+        </p:txBody>
+      </p:sp>
+      <p:sp>
+        <p:nvSpPr>
+          <p:cNvPr id="18" name="TextBox 17"/>
+          <p:cNvSpPr txBox="1"/>
+          <p:nvPr/>
+        </p:nvSpPr>
+        <p:spPr>
+          <a:xfrm>
+            <a:off x="4465320" y="3310128"/>
+            <a:ext cx="3230880" cy="548640"/>
+          </a:xfrm>
+          <a:prstGeom prst="rect">
+            <a:avLst/>
+          </a:prstGeom>
+          <a:noFill/>
+        </p:spPr>
+        <p:txBody>
+          <a:bodyPr wrap="square" anchor="t" lIns="0" rIns="0" tIns="0" bIns="0">
+            <a:spAutoFit/>
+          </a:bodyPr>
+          <a:lstStyle/>
+          <a:p>
+            <a:pPr algn="l">
+              <a:lnSpc>
+                <a:spcPct val="100000"/>
+              </a:lnSpc>
+              <a:spcBef>
+                <a:spcPts val="0"/>
+              </a:spcBef>
+              <a:spcAft>
+                <a:spcPts val="600"/>
+              </a:spcAft>
+            </a:pPr>
+            <a:r>
+              <a:rPr sz="1500" b="1">
                 <a:solidFill>
                   <a:srgbClr val="0F172A"/>
                 </a:solidFill>
@@ -14139,21 +14558,21 @@
                 <a:ea typeface="NanumGothic"/>
                 <a:cs typeface="NanumGothic"/>
               </a:rPr>
-              <a:t>검증 가능한 형태로</a:t>
-            </a:r>
-          </a:p>
-        </p:txBody>
-      </p:sp>
-      <p:sp>
-        <p:nvSpPr>
-          <p:cNvPr id="14" name="TextBox 13"/>
-          <p:cNvSpPr txBox="1"/>
-          <p:nvPr/>
-        </p:nvSpPr>
-        <p:spPr>
-          <a:xfrm>
-            <a:off x="868680" y="3081528"/>
-            <a:ext cx="10607040" cy="457200"/>
+              <a:t>조합 생성</a:t>
+            </a:r>
+          </a:p>
+        </p:txBody>
+      </p:sp>
+      <p:sp>
+        <p:nvSpPr>
+          <p:cNvPr id="19" name="TextBox 18"/>
+          <p:cNvSpPr txBox="1"/>
+          <p:nvPr/>
+        </p:nvSpPr>
+        <p:spPr>
+          <a:xfrm>
+            <a:off x="4465320" y="3822192"/>
+            <a:ext cx="3230880" cy="457200"/>
           </a:xfrm>
           <a:prstGeom prst="rect">
             <a:avLst/>
@@ -14178,7 +14597,7 @@
               </a:spcAft>
             </a:pPr>
             <a:r>
-              <a:rPr sz="1300" b="0">
+              <a:rPr sz="1100" b="0">
                 <a:solidFill>
                   <a:srgbClr val="64748B"/>
                 </a:solidFill>
@@ -14186,23 +14605,116 @@
                 <a:ea typeface="NanumGothic"/>
                 <a:cs typeface="NanumGothic"/>
               </a:rPr>
-              <a:t>'~한 조건에서 ~할 것이다' (한 문장)</a:t>
-            </a:r>
-          </a:p>
-        </p:txBody>
-      </p:sp>
-      <p:sp>
-        <p:nvSpPr>
-          <p:cNvPr id="15" name="Oval 14"/>
+              <a:t>배경+영감 → 가설</a:t>
+            </a:r>
+          </a:p>
+        </p:txBody>
+      </p:sp>
+      <p:sp>
+        <p:nvSpPr>
+          <p:cNvPr id="20" name="TextBox 19"/>
+          <p:cNvSpPr txBox="1"/>
+          <p:nvPr/>
+        </p:nvSpPr>
+        <p:spPr>
+          <a:xfrm>
+            <a:off x="7879080" y="3154680"/>
+            <a:ext cx="274320" cy="548640"/>
+          </a:xfrm>
+          <a:prstGeom prst="rect">
+            <a:avLst/>
+          </a:prstGeom>
+          <a:noFill/>
+        </p:spPr>
+        <p:txBody>
+          <a:bodyPr wrap="square" anchor="ctr" lIns="0" rIns="0" tIns="0" bIns="0">
+            <a:spAutoFit/>
+          </a:bodyPr>
+          <a:lstStyle/>
+          <a:p>
+            <a:pPr algn="ctr">
+              <a:lnSpc>
+                <a:spcPct val="100000"/>
+              </a:lnSpc>
+              <a:spcBef>
+                <a:spcPts val="0"/>
+              </a:spcBef>
+              <a:spcAft>
+                <a:spcPts val="600"/>
+              </a:spcAft>
+            </a:pPr>
+            <a:r>
+              <a:rPr sz="2200" b="1">
+                <a:solidFill>
+                  <a:srgbClr val="F59E0B"/>
+                </a:solidFill>
+                <a:latin typeface="NanumSquare"/>
+                <a:ea typeface="NanumSquare"/>
+                <a:cs typeface="NanumSquare"/>
+              </a:rPr>
+              <a:t>→</a:t>
+            </a:r>
+          </a:p>
+        </p:txBody>
+      </p:sp>
+      <p:sp>
+        <p:nvSpPr>
+          <p:cNvPr id="21" name="Rounded Rectangle 20"/>
           <p:cNvSpPr/>
           <p:nvPr/>
         </p:nvSpPr>
         <p:spPr>
           <a:xfrm>
-            <a:off x="548640" y="3648456"/>
-            <a:ext cx="146304" cy="146304"/>
-          </a:xfrm>
-          <a:prstGeom prst="ellipse">
+            <a:off x="8153400" y="2651760"/>
+            <a:ext cx="3505200" cy="1737360"/>
+          </a:xfrm>
+          <a:prstGeom prst="roundRect">
+            <a:avLst/>
+          </a:prstGeom>
+          <a:solidFill>
+            <a:srgbClr val="F8FAFC"/>
+          </a:solidFill>
+          <a:ln w="12700">
+            <a:solidFill>
+              <a:srgbClr val="E2E8F0"/>
+            </a:solidFill>
+          </a:ln>
+          <a:effectLst/>
+        </p:spPr>
+        <p:style>
+          <a:lnRef idx="1">
+            <a:schemeClr val="accent1"/>
+          </a:lnRef>
+          <a:fillRef idx="3">
+            <a:schemeClr val="accent1"/>
+          </a:fillRef>
+          <a:effectRef idx="2">
+            <a:schemeClr val="accent1"/>
+          </a:effectRef>
+          <a:fontRef idx="minor">
+            <a:schemeClr val="lt1"/>
+          </a:fontRef>
+        </p:style>
+        <p:txBody>
+          <a:bodyPr rtlCol="0" anchor="ctr"/>
+          <a:lstStyle/>
+          <a:p>
+            <a:pPr algn="ctr"/>
+          </a:p>
+        </p:txBody>
+      </p:sp>
+      <p:sp>
+        <p:nvSpPr>
+          <p:cNvPr id="22" name="Rectangle 21"/>
+          <p:cNvSpPr/>
+          <p:nvPr/>
+        </p:nvSpPr>
+        <p:spPr>
+          <a:xfrm>
+            <a:off x="8153400" y="2651760"/>
+            <a:ext cx="3505200" cy="109728"/>
+          </a:xfrm>
+          <a:prstGeom prst="rect">
             <a:avLst/>
           </a:prstGeom>
           <a:solidFill>
@@ -14237,14 +14749,14 @@
       </p:sp>
       <p:sp>
         <p:nvSpPr>
-          <p:cNvPr id="16" name="TextBox 15"/>
-          <p:cNvSpPr txBox="1"/>
-          <p:nvPr/>
-        </p:nvSpPr>
-        <p:spPr>
-          <a:xfrm>
-            <a:off x="868680" y="3566160"/>
-            <a:ext cx="10607040" cy="457200"/>
+          <p:cNvPr id="23" name="TextBox 22"/>
+          <p:cNvSpPr txBox="1"/>
+          <p:nvPr/>
+        </p:nvSpPr>
+        <p:spPr>
+          <a:xfrm>
+            <a:off x="8290560" y="2944368"/>
+            <a:ext cx="3230880" cy="365760"/>
           </a:xfrm>
           <a:prstGeom prst="rect">
             <a:avLst/>
@@ -14269,7 +14781,54 @@
               </a:spcAft>
             </a:pPr>
             <a:r>
-              <a:rPr sz="1600" b="1">
+              <a:rPr sz="1300" b="1">
+                <a:solidFill>
+                  <a:srgbClr val="F59E0B"/>
+                </a:solidFill>
+                <a:latin typeface="NanumSquare"/>
+                <a:ea typeface="NanumSquare"/>
+                <a:cs typeface="NanumSquare"/>
+              </a:rPr>
+              <a:t>3</a:t>
+            </a:r>
+          </a:p>
+        </p:txBody>
+      </p:sp>
+      <p:sp>
+        <p:nvSpPr>
+          <p:cNvPr id="24" name="TextBox 23"/>
+          <p:cNvSpPr txBox="1"/>
+          <p:nvPr/>
+        </p:nvSpPr>
+        <p:spPr>
+          <a:xfrm>
+            <a:off x="8290560" y="3310128"/>
+            <a:ext cx="3230880" cy="548640"/>
+          </a:xfrm>
+          <a:prstGeom prst="rect">
+            <a:avLst/>
+          </a:prstGeom>
+          <a:noFill/>
+        </p:spPr>
+        <p:txBody>
+          <a:bodyPr wrap="square" anchor="t" lIns="0" rIns="0" tIns="0" bIns="0">
+            <a:spAutoFit/>
+          </a:bodyPr>
+          <a:lstStyle/>
+          <a:p>
+            <a:pPr algn="l">
+              <a:lnSpc>
+                <a:spcPct val="100000"/>
+              </a:lnSpc>
+              <a:spcBef>
+                <a:spcPts val="0"/>
+              </a:spcBef>
+              <a:spcAft>
+                <a:spcPts val="600"/>
+              </a:spcAft>
+            </a:pPr>
+            <a:r>
+              <a:rPr sz="1500" b="1">
                 <a:solidFill>
                   <a:srgbClr val="0F172A"/>
                 </a:solidFill>
@@ -14277,21 +14836,21 @@
                 <a:ea typeface="NanumGothic"/>
                 <a:cs typeface="NanumGothic"/>
               </a:rPr>
-              <a:t>근거 태그</a:t>
-            </a:r>
-          </a:p>
-        </p:txBody>
-      </p:sp>
-      <p:sp>
-        <p:nvSpPr>
-          <p:cNvPr id="17" name="TextBox 16"/>
-          <p:cNvSpPr txBox="1"/>
-          <p:nvPr/>
-        </p:nvSpPr>
-        <p:spPr>
-          <a:xfrm>
-            <a:off x="868680" y="3950208"/>
-            <a:ext cx="10607040" cy="457200"/>
+              <a:t>순위</a:t>
+            </a:r>
+          </a:p>
+        </p:txBody>
+      </p:sp>
+      <p:sp>
+        <p:nvSpPr>
+          <p:cNvPr id="25" name="TextBox 24"/>
+          <p:cNvSpPr txBox="1"/>
+          <p:nvPr/>
+        </p:nvSpPr>
+        <p:spPr>
+          <a:xfrm>
+            <a:off x="8290560" y="3822192"/>
+            <a:ext cx="3230880" cy="457200"/>
           </a:xfrm>
           <a:prstGeom prst="rect">
             <a:avLst/>
@@ -14316,7 +14875,7 @@
               </a:spcAft>
             </a:pPr>
             <a:r>
-              <a:rPr sz="1300" b="0">
+              <a:rPr sz="1100" b="0">
                 <a:solidFill>
                   <a:srgbClr val="64748B"/>
                 </a:solidFill>
@@ -14324,20 +14883,20 @@
                 <a:ea typeface="NanumGothic"/>
                 <a:cs typeface="NanumGothic"/>
               </a:rPr>
-              <a:t>어느 gap·논문에서 나왔는지 표기</a:t>
-            </a:r>
-          </a:p>
-        </p:txBody>
-      </p:sp>
-      <p:sp>
-        <p:nvSpPr>
-          <p:cNvPr id="18" name="Rounded Rectangle 17"/>
+              <a:t>평가·랭킹</a:t>
+            </a:r>
+          </a:p>
+        </p:txBody>
+      </p:sp>
+      <p:sp>
+        <p:nvSpPr>
+          <p:cNvPr id="26" name="Rounded Rectangle 25"/>
           <p:cNvSpPr/>
           <p:nvPr/>
         </p:nvSpPr>
         <p:spPr>
           <a:xfrm>
-            <a:off x="502920" y="5532120"/>
+            <a:off x="502920" y="5029200"/>
             <a:ext cx="11155680" cy="658368"/>
           </a:xfrm>
           <a:prstGeom prst="roundRect">
@@ -14377,13 +14936,13 @@
       </p:sp>
       <p:sp>
         <p:nvSpPr>
-          <p:cNvPr id="19" name="TextBox 18"/>
-          <p:cNvSpPr txBox="1"/>
-          <p:nvPr/>
-        </p:nvSpPr>
-        <p:spPr>
-          <a:xfrm>
-            <a:off x="777240" y="5532120"/>
+          <p:cNvPr id="27" name="TextBox 26"/>
+          <p:cNvSpPr txBox="1"/>
+          <p:nvPr/>
+        </p:nvSpPr>
+        <p:spPr>
+          <a:xfrm>
+            <a:off x="777240" y="5029200"/>
             <a:ext cx="10607040" cy="658368"/>
           </a:xfrm>
           <a:prstGeom prst="rect">
@@ -14428,7 +14987,7 @@
                 <a:ea typeface="NanumGothic"/>
                 <a:cs typeface="NanumGothic"/>
               </a:rPr>
-              <a:t>예: '단시간 수면자는 특정 유전형에서 인지저하가 덜할 것이다'</a:t>
+              <a:t>연구로 검증된 3단계 (MOOSE-Chem, ICLR'25 · 화학) — 우리는 간소화해 차용</a:t>
             </a:r>
           </a:p>
         </p:txBody>
@@ -14581,7 +15140,7 @@
                 <a:ea typeface="NanumGothic"/>
                 <a:cs typeface="NanumGothic"/>
               </a:rPr>
-              <a:t>평가·우선순위</a:t>
+              <a:t>가설 생성</a:t>
             </a:r>
           </a:p>
         </p:txBody>
@@ -14628,7 +15187,7 @@
                 <a:ea typeface="NanumSquare"/>
                 <a:cs typeface="NanumSquare"/>
               </a:rPr>
-              <a:t>생성 → 선별 (강의 쟁점 적용)</a:t>
+              <a:t>가설 만들기 — 두 갈래</a:t>
             </a:r>
           </a:p>
         </p:txBody>
@@ -14903,7 +15462,7 @@
                 <a:ea typeface="NanumSquare"/>
                 <a:cs typeface="NanumSquare"/>
               </a:rPr>
-              <a:t>생성 (breadth)</a:t>
+              <a:t>gap 기반</a:t>
             </a:r>
           </a:p>
         </p:txBody>
@@ -14961,7 +15520,7 @@
                 <a:ea typeface="NanumGothic"/>
                 <a:cs typeface="NanumGothic"/>
               </a:rPr>
-              <a:t>많이·다양하게</a:t>
+              <a:t>모순·미검증·공백에서</a:t>
             </a:r>
           </a:p>
         </p:txBody>
@@ -15019,7 +15578,7 @@
                 <a:ea typeface="NanumGothic"/>
                 <a:cs typeface="NanumGothic"/>
               </a:rPr>
-              <a:t>데이터/도구로 제약</a:t>
+              <a:t>'~조건에서 ~할 것이다'</a:t>
             </a:r>
           </a:p>
         </p:txBody>
@@ -15077,7 +15636,7 @@
                 <a:ea typeface="NanumGothic"/>
                 <a:cs typeface="NanumGothic"/>
               </a:rPr>
-              <a:t>이미 있는 건 제외</a:t>
+              <a:t>근거: 어느 gap</a:t>
             </a:r>
           </a:p>
         </p:txBody>
@@ -15214,7 +15773,7 @@
                 <a:ea typeface="NanumSquare"/>
                 <a:cs typeface="NanumSquare"/>
               </a:rPr>
-              <a:t>선별 (우선순위)</a:t>
+              <a:t>조합(영감) 기반</a:t>
             </a:r>
           </a:p>
         </p:txBody>
@@ -15272,7 +15831,7 @@
                 <a:ea typeface="NanumGothic"/>
                 <a:cs typeface="NanumGothic"/>
               </a:rPr>
-              <a:t>근거·새로움·중요성</a:t>
+              <a:t>다른 논문 아이디어를 끌어와</a:t>
             </a:r>
           </a:p>
         </p:txBody>
@@ -15330,7 +15889,7 @@
                 <a:ea typeface="NanumGothic"/>
                 <a:cs typeface="NanumGothic"/>
               </a:rPr>
-              <a:t>검증 가능성</a:t>
+              <a:t>배경 + 영감 = 새 가설</a:t>
             </a:r>
           </a:p>
         </p:txBody>
@@ -15388,7 +15947,7 @@
                 <a:ea typeface="NanumGothic"/>
                 <a:cs typeface="NanumGothic"/>
               </a:rPr>
-              <a:t>상위 1~2개 추리기</a:t>
+              <a:t>근거: 어느 논문</a:t>
             </a:r>
           </a:p>
         </p:txBody>
@@ -15541,7 +16100,7 @@
                 <a:ea typeface="NanumGothic"/>
                 <a:cs typeface="NanumGothic"/>
               </a:rPr>
-              <a:t>점검</a:t>
+              <a:t>생성 원칙</a:t>
             </a:r>
           </a:p>
         </p:txBody>
@@ -15588,7 +16147,7 @@
                 <a:ea typeface="NanumSquare"/>
                 <a:cs typeface="NanumSquare"/>
               </a:rPr>
-              <a:t>제안 전 마지막 점검</a:t>
+              <a:t>많이·다양하게 — 그리고 제약</a:t>
             </a:r>
           </a:p>
         </p:txBody>
@@ -15817,7 +16376,7 @@
                 <a:ea typeface="NanumGothic"/>
                 <a:cs typeface="NanumGothic"/>
               </a:rPr>
-              <a:t>근거 있나?</a:t>
+              <a:t>각 갈래에서 여러 개</a:t>
             </a:r>
           </a:p>
         </p:txBody>
@@ -15864,7 +16423,7 @@
                 <a:ea typeface="NanumGothic"/>
                 <a:cs typeface="NanumGothic"/>
               </a:rPr>
-              <a:t>막연한 상상 아닌, gap·출처 기반</a:t>
+              <a:t>하나가 아니라 6~10개 — breadth</a:t>
             </a:r>
           </a:p>
         </p:txBody>
@@ -15955,7 +16514,7 @@
                 <a:ea typeface="NanumGothic"/>
                 <a:cs typeface="NanumGothic"/>
               </a:rPr>
-              <a:t>새로운가?</a:t>
+              <a:t>검증 가능·근거 태그</a:t>
             </a:r>
           </a:p>
         </p:txBody>
@@ -16002,7 +16561,7 @@
                 <a:ea typeface="NanumGothic"/>
                 <a:cs typeface="NanumGothic"/>
               </a:rPr>
-              <a:t>기존 논문에 이미 있는 건 아닌지</a:t>
+              <a:t>한 문장 + 어디서 나왔는지</a:t>
             </a:r>
           </a:p>
         </p:txBody>
@@ -16093,7 +16652,7 @@
                 <a:ea typeface="NanumGothic"/>
                 <a:cs typeface="NanumGothic"/>
               </a:rPr>
-              <a:t>검증 아이디어 있나?</a:t>
+              <a:t>이미 있는 건 제외</a:t>
             </a:r>
           </a:p>
         </p:txBody>
@@ -16140,7 +16699,7 @@
                 <a:ea typeface="NanumGothic"/>
                 <a:cs typeface="NanumGothic"/>
               </a:rPr>
-              <a:t>어떻게 확인할지 한 줄이라도</a:t>
+              <a:t>가용 데이터/도구로 제약</a:t>
             </a:r>
           </a:p>
         </p:txBody>
@@ -16244,7 +16803,7 @@
                 <a:ea typeface="NanumGothic"/>
                 <a:cs typeface="NanumGothic"/>
               </a:rPr>
-              <a:t>약하면 되돌아가 재생성·보강 (iteration)</a:t>
+              <a:t>예: '단시간 수면자는 특정 유전형에서 인지저하가 덜할 것이다'</a:t>
             </a:r>
           </a:p>
         </p:txBody>
@@ -16397,7 +16956,7 @@
                 <a:ea typeface="NanumGothic"/>
                 <a:cs typeface="NanumGothic"/>
               </a:rPr>
-              <a:t>LAB · 실습</a:t>
+              <a:t>평가·우선순위</a:t>
             </a:r>
           </a:p>
         </p:txBody>
@@ -16444,7 +17003,7 @@
                 <a:ea typeface="NanumSquare"/>
                 <a:cs typeface="NanumSquare"/>
               </a:rPr>
-              <a:t>가설 생성·평가 → 제안 확정</a:t>
+              <a:t>생성 → 선별 (강의 쟁점 적용)</a:t>
             </a:r>
           </a:p>
         </p:txBody>
@@ -16595,8 +17154,8 @@
         </p:nvSpPr>
         <p:spPr>
           <a:xfrm>
-            <a:off x="502920" y="1783080"/>
-            <a:ext cx="7315200" cy="4160520"/>
+            <a:off x="502920" y="1828800"/>
+            <a:ext cx="5440680" cy="4023360"/>
           </a:xfrm>
           <a:prstGeom prst="roundRect">
             <a:avLst/>
@@ -16635,63 +17194,16 @@
       </p:sp>
       <p:sp>
         <p:nvSpPr>
-          <p:cNvPr id="10" name="TextBox 9"/>
-          <p:cNvSpPr txBox="1"/>
-          <p:nvPr/>
-        </p:nvSpPr>
-        <p:spPr>
-          <a:xfrm>
-            <a:off x="777240" y="1965960"/>
-            <a:ext cx="6766560" cy="365760"/>
-          </a:xfrm>
-          <a:prstGeom prst="rect">
-            <a:avLst/>
-          </a:prstGeom>
-          <a:noFill/>
-        </p:spPr>
-        <p:txBody>
-          <a:bodyPr wrap="square" anchor="t" lIns="0" rIns="0" tIns="0" bIns="0">
-            <a:spAutoFit/>
-          </a:bodyPr>
-          <a:lstStyle/>
-          <a:p>
-            <a:pPr algn="l">
-              <a:lnSpc>
-                <a:spcPct val="100000"/>
-              </a:lnSpc>
-              <a:spcBef>
-                <a:spcPts val="0"/>
-              </a:spcBef>
-              <a:spcAft>
-                <a:spcPts val="600"/>
-              </a:spcAft>
-            </a:pPr>
-            <a:r>
-              <a:rPr sz="1300" b="1">
-                <a:solidFill>
-                  <a:srgbClr val="F59E0B"/>
-                </a:solidFill>
-                <a:latin typeface="NanumGothic"/>
-                <a:ea typeface="NanumGothic"/>
-                <a:cs typeface="NanumGothic"/>
-              </a:rPr>
-              <a:t>실습 단계</a:t>
-            </a:r>
-          </a:p>
-        </p:txBody>
-      </p:sp>
-      <p:sp>
-        <p:nvSpPr>
-          <p:cNvPr id="11" name="Oval 10"/>
+          <p:cNvPr id="10" name="Rounded Rectangle 9"/>
           <p:cNvSpPr/>
           <p:nvPr/>
         </p:nvSpPr>
         <p:spPr>
           <a:xfrm>
-            <a:off x="777240" y="2468880"/>
-            <a:ext cx="411480" cy="411480"/>
-          </a:xfrm>
-          <a:prstGeom prst="ellipse">
+            <a:off x="502920" y="1828800"/>
+            <a:ext cx="5440680" cy="640080"/>
+          </a:xfrm>
+          <a:prstGeom prst="roundRect">
             <a:avLst/>
           </a:prstGeom>
           <a:solidFill>
@@ -16726,14 +17238,14 @@
       </p:sp>
       <p:sp>
         <p:nvSpPr>
-          <p:cNvPr id="12" name="TextBox 11"/>
-          <p:cNvSpPr txBox="1"/>
-          <p:nvPr/>
-        </p:nvSpPr>
-        <p:spPr>
-          <a:xfrm>
-            <a:off x="777240" y="2468880"/>
-            <a:ext cx="411480" cy="411480"/>
+          <p:cNvPr id="11" name="TextBox 10"/>
+          <p:cNvSpPr txBox="1"/>
+          <p:nvPr/>
+        </p:nvSpPr>
+        <p:spPr>
+          <a:xfrm>
+            <a:off x="777240" y="1828800"/>
+            <a:ext cx="4937760" cy="640080"/>
           </a:xfrm>
           <a:prstGeom prst="rect">
             <a:avLst/>
@@ -16746,19 +17258,19 @@
           </a:bodyPr>
           <a:lstStyle/>
           <a:p>
-            <a:pPr algn="ctr">
-              <a:lnSpc>
-                <a:spcPct val="100000"/>
-              </a:lnSpc>
-              <a:spcBef>
-                <a:spcPts val="0"/>
-              </a:spcBef>
-              <a:spcAft>
-                <a:spcPts val="600"/>
-              </a:spcAft>
-            </a:pPr>
-            <a:r>
-              <a:rPr sz="1300" b="1">
+            <a:pPr algn="l">
+              <a:lnSpc>
+                <a:spcPct val="100000"/>
+              </a:lnSpc>
+              <a:spcBef>
+                <a:spcPts val="0"/>
+              </a:spcBef>
+              <a:spcAft>
+                <a:spcPts val="600"/>
+              </a:spcAft>
+            </a:pPr>
+            <a:r>
+              <a:rPr sz="1600" b="1">
                 <a:solidFill>
                   <a:srgbClr val="FFFFFF"/>
                 </a:solidFill>
@@ -16766,29 +17278,29 @@
                 <a:ea typeface="NanumSquare"/>
                 <a:cs typeface="NanumSquare"/>
               </a:rPr>
-              <a:t>1</a:t>
-            </a:r>
-          </a:p>
-        </p:txBody>
-      </p:sp>
-      <p:sp>
-        <p:nvSpPr>
-          <p:cNvPr id="13" name="TextBox 12"/>
-          <p:cNvSpPr txBox="1"/>
-          <p:nvPr/>
-        </p:nvSpPr>
-        <p:spPr>
-          <a:xfrm>
-            <a:off x="1371600" y="2487168"/>
-            <a:ext cx="6309360" cy="457200"/>
-          </a:xfrm>
-          <a:prstGeom prst="rect">
-            <a:avLst/>
-          </a:prstGeom>
-          <a:noFill/>
-        </p:spPr>
-        <p:txBody>
-          <a:bodyPr wrap="square" anchor="ctr" lIns="0" rIns="0" tIns="0" bIns="0">
+              <a:t>생성 (breadth)</a:t>
+            </a:r>
+          </a:p>
+        </p:txBody>
+      </p:sp>
+      <p:sp>
+        <p:nvSpPr>
+          <p:cNvPr id="12" name="TextBox 11"/>
+          <p:cNvSpPr txBox="1"/>
+          <p:nvPr/>
+        </p:nvSpPr>
+        <p:spPr>
+          <a:xfrm>
+            <a:off x="822960" y="2697480"/>
+            <a:ext cx="4846320" cy="548640"/>
+          </a:xfrm>
+          <a:prstGeom prst="rect">
+            <a:avLst/>
+          </a:prstGeom>
+          <a:noFill/>
+        </p:spPr>
+        <p:txBody>
+          <a:bodyPr wrap="square" anchor="t" lIns="0" rIns="0" tIns="0" bIns="0">
             <a:spAutoFit/>
           </a:bodyPr>
           <a:lstStyle/>
@@ -16805,38 +17317,167 @@
               </a:spcAft>
             </a:pPr>
             <a:r>
-              <a:rPr sz="1400" b="0">
-                <a:solidFill>
-                  <a:srgbClr val="0F172A"/>
+              <a:rPr sz="1400" b="1">
+                <a:solidFill>
+                  <a:srgbClr val="F59E0B"/>
                 </a:solidFill>
                 <a:latin typeface="NanumGothic"/>
                 <a:ea typeface="NanumGothic"/>
                 <a:cs typeface="NanumGothic"/>
               </a:rPr>
-              <a:t>gap에서 가설 다수 생성</a:t>
-            </a:r>
-          </a:p>
-        </p:txBody>
-      </p:sp>
-      <p:sp>
-        <p:nvSpPr>
-          <p:cNvPr id="14" name="Oval 13"/>
+              <a:t>•  </a:t>
+            </a:r>
+            <a:r>
+              <a:rPr sz="1400" b="0">
+                <a:solidFill>
+                  <a:srgbClr val="0F172A"/>
+                </a:solidFill>
+                <a:latin typeface="NanumGothic"/>
+                <a:ea typeface="NanumGothic"/>
+                <a:cs typeface="NanumGothic"/>
+              </a:rPr>
+              <a:t>많이·다양하게</a:t>
+            </a:r>
+          </a:p>
+        </p:txBody>
+      </p:sp>
+      <p:sp>
+        <p:nvSpPr>
+          <p:cNvPr id="13" name="TextBox 12"/>
+          <p:cNvSpPr txBox="1"/>
+          <p:nvPr/>
+        </p:nvSpPr>
+        <p:spPr>
+          <a:xfrm>
+            <a:off x="822960" y="3264408"/>
+            <a:ext cx="4846320" cy="548640"/>
+          </a:xfrm>
+          <a:prstGeom prst="rect">
+            <a:avLst/>
+          </a:prstGeom>
+          <a:noFill/>
+        </p:spPr>
+        <p:txBody>
+          <a:bodyPr wrap="square" anchor="t" lIns="0" rIns="0" tIns="0" bIns="0">
+            <a:spAutoFit/>
+          </a:bodyPr>
+          <a:lstStyle/>
+          <a:p>
+            <a:pPr algn="l">
+              <a:lnSpc>
+                <a:spcPct val="100000"/>
+              </a:lnSpc>
+              <a:spcBef>
+                <a:spcPts val="0"/>
+              </a:spcBef>
+              <a:spcAft>
+                <a:spcPts val="600"/>
+              </a:spcAft>
+            </a:pPr>
+            <a:r>
+              <a:rPr sz="1400" b="1">
+                <a:solidFill>
+                  <a:srgbClr val="F59E0B"/>
+                </a:solidFill>
+                <a:latin typeface="NanumGothic"/>
+                <a:ea typeface="NanumGothic"/>
+                <a:cs typeface="NanumGothic"/>
+              </a:rPr>
+              <a:t>•  </a:t>
+            </a:r>
+            <a:r>
+              <a:rPr sz="1400" b="0">
+                <a:solidFill>
+                  <a:srgbClr val="0F172A"/>
+                </a:solidFill>
+                <a:latin typeface="NanumGothic"/>
+                <a:ea typeface="NanumGothic"/>
+                <a:cs typeface="NanumGothic"/>
+              </a:rPr>
+              <a:t>데이터/도구로 제약</a:t>
+            </a:r>
+          </a:p>
+        </p:txBody>
+      </p:sp>
+      <p:sp>
+        <p:nvSpPr>
+          <p:cNvPr id="14" name="TextBox 13"/>
+          <p:cNvSpPr txBox="1"/>
+          <p:nvPr/>
+        </p:nvSpPr>
+        <p:spPr>
+          <a:xfrm>
+            <a:off x="822960" y="3831336"/>
+            <a:ext cx="4846320" cy="548640"/>
+          </a:xfrm>
+          <a:prstGeom prst="rect">
+            <a:avLst/>
+          </a:prstGeom>
+          <a:noFill/>
+        </p:spPr>
+        <p:txBody>
+          <a:bodyPr wrap="square" anchor="t" lIns="0" rIns="0" tIns="0" bIns="0">
+            <a:spAutoFit/>
+          </a:bodyPr>
+          <a:lstStyle/>
+          <a:p>
+            <a:pPr algn="l">
+              <a:lnSpc>
+                <a:spcPct val="100000"/>
+              </a:lnSpc>
+              <a:spcBef>
+                <a:spcPts val="0"/>
+              </a:spcBef>
+              <a:spcAft>
+                <a:spcPts val="600"/>
+              </a:spcAft>
+            </a:pPr>
+            <a:r>
+              <a:rPr sz="1400" b="1">
+                <a:solidFill>
+                  <a:srgbClr val="F59E0B"/>
+                </a:solidFill>
+                <a:latin typeface="NanumGothic"/>
+                <a:ea typeface="NanumGothic"/>
+                <a:cs typeface="NanumGothic"/>
+              </a:rPr>
+              <a:t>•  </a:t>
+            </a:r>
+            <a:r>
+              <a:rPr sz="1400" b="0">
+                <a:solidFill>
+                  <a:srgbClr val="0F172A"/>
+                </a:solidFill>
+                <a:latin typeface="NanumGothic"/>
+                <a:ea typeface="NanumGothic"/>
+                <a:cs typeface="NanumGothic"/>
+              </a:rPr>
+              <a:t>이미 있는 건 제외</a:t>
+            </a:r>
+          </a:p>
+        </p:txBody>
+      </p:sp>
+      <p:sp>
+        <p:nvSpPr>
+          <p:cNvPr id="15" name="Rounded Rectangle 14"/>
           <p:cNvSpPr/>
           <p:nvPr/>
         </p:nvSpPr>
         <p:spPr>
           <a:xfrm>
-            <a:off x="777240" y="3035808"/>
-            <a:ext cx="411480" cy="411480"/>
-          </a:xfrm>
-          <a:prstGeom prst="ellipse">
+            <a:off x="6172200" y="1828800"/>
+            <a:ext cx="5440680" cy="4023360"/>
+          </a:xfrm>
+          <a:prstGeom prst="roundRect">
             <a:avLst/>
           </a:prstGeom>
           <a:solidFill>
-            <a:srgbClr val="F59E0B"/>
+            <a:srgbClr val="F8FAFC"/>
           </a:solidFill>
-          <a:ln>
-            <a:noFill/>
+          <a:ln w="12700">
+            <a:solidFill>
+              <a:srgbClr val="E2E8F0"/>
+            </a:solidFill>
           </a:ln>
           <a:effectLst/>
         </p:spPr>
@@ -16864,384 +17505,14 @@
       </p:sp>
       <p:sp>
         <p:nvSpPr>
-          <p:cNvPr id="15" name="TextBox 14"/>
-          <p:cNvSpPr txBox="1"/>
-          <p:nvPr/>
-        </p:nvSpPr>
-        <p:spPr>
-          <a:xfrm>
-            <a:off x="777240" y="3035808"/>
-            <a:ext cx="411480" cy="411480"/>
-          </a:xfrm>
-          <a:prstGeom prst="rect">
-            <a:avLst/>
-          </a:prstGeom>
-          <a:noFill/>
-        </p:spPr>
-        <p:txBody>
-          <a:bodyPr wrap="square" anchor="ctr" lIns="0" rIns="0" tIns="0" bIns="0">
-            <a:spAutoFit/>
-          </a:bodyPr>
-          <a:lstStyle/>
-          <a:p>
-            <a:pPr algn="ctr">
-              <a:lnSpc>
-                <a:spcPct val="100000"/>
-              </a:lnSpc>
-              <a:spcBef>
-                <a:spcPts val="0"/>
-              </a:spcBef>
-              <a:spcAft>
-                <a:spcPts val="600"/>
-              </a:spcAft>
-            </a:pPr>
-            <a:r>
-              <a:rPr sz="1300" b="1">
-                <a:solidFill>
-                  <a:srgbClr val="FFFFFF"/>
-                </a:solidFill>
-                <a:latin typeface="NanumSquare"/>
-                <a:ea typeface="NanumSquare"/>
-                <a:cs typeface="NanumSquare"/>
-              </a:rPr>
-              <a:t>2</a:t>
-            </a:r>
-          </a:p>
-        </p:txBody>
-      </p:sp>
-      <p:sp>
-        <p:nvSpPr>
-          <p:cNvPr id="16" name="TextBox 15"/>
-          <p:cNvSpPr txBox="1"/>
-          <p:nvPr/>
-        </p:nvSpPr>
-        <p:spPr>
-          <a:xfrm>
-            <a:off x="1371600" y="3054096"/>
-            <a:ext cx="6309360" cy="457200"/>
-          </a:xfrm>
-          <a:prstGeom prst="rect">
-            <a:avLst/>
-          </a:prstGeom>
-          <a:noFill/>
-        </p:spPr>
-        <p:txBody>
-          <a:bodyPr wrap="square" anchor="ctr" lIns="0" rIns="0" tIns="0" bIns="0">
-            <a:spAutoFit/>
-          </a:bodyPr>
-          <a:lstStyle/>
-          <a:p>
-            <a:pPr algn="l">
-              <a:lnSpc>
-                <a:spcPct val="100000"/>
-              </a:lnSpc>
-              <a:spcBef>
-                <a:spcPts val="0"/>
-              </a:spcBef>
-              <a:spcAft>
-                <a:spcPts val="600"/>
-              </a:spcAft>
-            </a:pPr>
-            <a:r>
-              <a:rPr sz="1400" b="0">
-                <a:solidFill>
-                  <a:srgbClr val="0F172A"/>
-                </a:solidFill>
-                <a:latin typeface="NanumGothic"/>
-                <a:ea typeface="NanumGothic"/>
-                <a:cs typeface="NanumGothic"/>
-              </a:rPr>
-              <a:t>기준별 평가·점수·랭킹</a:t>
-            </a:r>
-          </a:p>
-        </p:txBody>
-      </p:sp>
-      <p:sp>
-        <p:nvSpPr>
-          <p:cNvPr id="17" name="Oval 16"/>
+          <p:cNvPr id="16" name="Rounded Rectangle 15"/>
           <p:cNvSpPr/>
           <p:nvPr/>
         </p:nvSpPr>
         <p:spPr>
           <a:xfrm>
-            <a:off x="777240" y="3602736"/>
-            <a:ext cx="411480" cy="411480"/>
-          </a:xfrm>
-          <a:prstGeom prst="ellipse">
-            <a:avLst/>
-          </a:prstGeom>
-          <a:solidFill>
-            <a:srgbClr val="F59E0B"/>
-          </a:solidFill>
-          <a:ln>
-            <a:noFill/>
-          </a:ln>
-          <a:effectLst/>
-        </p:spPr>
-        <p:style>
-          <a:lnRef idx="1">
-            <a:schemeClr val="accent1"/>
-          </a:lnRef>
-          <a:fillRef idx="3">
-            <a:schemeClr val="accent1"/>
-          </a:fillRef>
-          <a:effectRef idx="2">
-            <a:schemeClr val="accent1"/>
-          </a:effectRef>
-          <a:fontRef idx="minor">
-            <a:schemeClr val="lt1"/>
-          </a:fontRef>
-        </p:style>
-        <p:txBody>
-          <a:bodyPr rtlCol="0" anchor="ctr"/>
-          <a:lstStyle/>
-          <a:p>
-            <a:pPr algn="ctr"/>
-          </a:p>
-        </p:txBody>
-      </p:sp>
-      <p:sp>
-        <p:nvSpPr>
-          <p:cNvPr id="18" name="TextBox 17"/>
-          <p:cNvSpPr txBox="1"/>
-          <p:nvPr/>
-        </p:nvSpPr>
-        <p:spPr>
-          <a:xfrm>
-            <a:off x="777240" y="3602736"/>
-            <a:ext cx="411480" cy="411480"/>
-          </a:xfrm>
-          <a:prstGeom prst="rect">
-            <a:avLst/>
-          </a:prstGeom>
-          <a:noFill/>
-        </p:spPr>
-        <p:txBody>
-          <a:bodyPr wrap="square" anchor="ctr" lIns="0" rIns="0" tIns="0" bIns="0">
-            <a:spAutoFit/>
-          </a:bodyPr>
-          <a:lstStyle/>
-          <a:p>
-            <a:pPr algn="ctr">
-              <a:lnSpc>
-                <a:spcPct val="100000"/>
-              </a:lnSpc>
-              <a:spcBef>
-                <a:spcPts val="0"/>
-              </a:spcBef>
-              <a:spcAft>
-                <a:spcPts val="600"/>
-              </a:spcAft>
-            </a:pPr>
-            <a:r>
-              <a:rPr sz="1300" b="1">
-                <a:solidFill>
-                  <a:srgbClr val="FFFFFF"/>
-                </a:solidFill>
-                <a:latin typeface="NanumSquare"/>
-                <a:ea typeface="NanumSquare"/>
-                <a:cs typeface="NanumSquare"/>
-              </a:rPr>
-              <a:t>3</a:t>
-            </a:r>
-          </a:p>
-        </p:txBody>
-      </p:sp>
-      <p:sp>
-        <p:nvSpPr>
-          <p:cNvPr id="19" name="TextBox 18"/>
-          <p:cNvSpPr txBox="1"/>
-          <p:nvPr/>
-        </p:nvSpPr>
-        <p:spPr>
-          <a:xfrm>
-            <a:off x="1371600" y="3621024"/>
-            <a:ext cx="6309360" cy="457200"/>
-          </a:xfrm>
-          <a:prstGeom prst="rect">
-            <a:avLst/>
-          </a:prstGeom>
-          <a:noFill/>
-        </p:spPr>
-        <p:txBody>
-          <a:bodyPr wrap="square" anchor="ctr" lIns="0" rIns="0" tIns="0" bIns="0">
-            <a:spAutoFit/>
-          </a:bodyPr>
-          <a:lstStyle/>
-          <a:p>
-            <a:pPr algn="l">
-              <a:lnSpc>
-                <a:spcPct val="100000"/>
-              </a:lnSpc>
-              <a:spcBef>
-                <a:spcPts val="0"/>
-              </a:spcBef>
-              <a:spcAft>
-                <a:spcPts val="600"/>
-              </a:spcAft>
-            </a:pPr>
-            <a:r>
-              <a:rPr sz="1400" b="0">
-                <a:solidFill>
-                  <a:srgbClr val="0F172A"/>
-                </a:solidFill>
-                <a:latin typeface="NanumGothic"/>
-                <a:ea typeface="NanumGothic"/>
-                <a:cs typeface="NanumGothic"/>
-              </a:rPr>
-              <a:t>우선순위 1~2개 + rationale 보강</a:t>
-            </a:r>
-          </a:p>
-        </p:txBody>
-      </p:sp>
-      <p:sp>
-        <p:nvSpPr>
-          <p:cNvPr id="20" name="Oval 19"/>
-          <p:cNvSpPr/>
-          <p:nvPr/>
-        </p:nvSpPr>
-        <p:spPr>
-          <a:xfrm>
-            <a:off x="777240" y="4169664"/>
-            <a:ext cx="411480" cy="411480"/>
-          </a:xfrm>
-          <a:prstGeom prst="ellipse">
-            <a:avLst/>
-          </a:prstGeom>
-          <a:solidFill>
-            <a:srgbClr val="F59E0B"/>
-          </a:solidFill>
-          <a:ln>
-            <a:noFill/>
-          </a:ln>
-          <a:effectLst/>
-        </p:spPr>
-        <p:style>
-          <a:lnRef idx="1">
-            <a:schemeClr val="accent1"/>
-          </a:lnRef>
-          <a:fillRef idx="3">
-            <a:schemeClr val="accent1"/>
-          </a:fillRef>
-          <a:effectRef idx="2">
-            <a:schemeClr val="accent1"/>
-          </a:effectRef>
-          <a:fontRef idx="minor">
-            <a:schemeClr val="lt1"/>
-          </a:fontRef>
-        </p:style>
-        <p:txBody>
-          <a:bodyPr rtlCol="0" anchor="ctr"/>
-          <a:lstStyle/>
-          <a:p>
-            <a:pPr algn="ctr"/>
-          </a:p>
-        </p:txBody>
-      </p:sp>
-      <p:sp>
-        <p:nvSpPr>
-          <p:cNvPr id="21" name="TextBox 20"/>
-          <p:cNvSpPr txBox="1"/>
-          <p:nvPr/>
-        </p:nvSpPr>
-        <p:spPr>
-          <a:xfrm>
-            <a:off x="777240" y="4169664"/>
-            <a:ext cx="411480" cy="411480"/>
-          </a:xfrm>
-          <a:prstGeom prst="rect">
-            <a:avLst/>
-          </a:prstGeom>
-          <a:noFill/>
-        </p:spPr>
-        <p:txBody>
-          <a:bodyPr wrap="square" anchor="ctr" lIns="0" rIns="0" tIns="0" bIns="0">
-            <a:spAutoFit/>
-          </a:bodyPr>
-          <a:lstStyle/>
-          <a:p>
-            <a:pPr algn="ctr">
-              <a:lnSpc>
-                <a:spcPct val="100000"/>
-              </a:lnSpc>
-              <a:spcBef>
-                <a:spcPts val="0"/>
-              </a:spcBef>
-              <a:spcAft>
-                <a:spcPts val="600"/>
-              </a:spcAft>
-            </a:pPr>
-            <a:r>
-              <a:rPr sz="1300" b="1">
-                <a:solidFill>
-                  <a:srgbClr val="FFFFFF"/>
-                </a:solidFill>
-                <a:latin typeface="NanumSquare"/>
-                <a:ea typeface="NanumSquare"/>
-                <a:cs typeface="NanumSquare"/>
-              </a:rPr>
-              <a:t>4</a:t>
-            </a:r>
-          </a:p>
-        </p:txBody>
-      </p:sp>
-      <p:sp>
-        <p:nvSpPr>
-          <p:cNvPr id="22" name="TextBox 21"/>
-          <p:cNvSpPr txBox="1"/>
-          <p:nvPr/>
-        </p:nvSpPr>
-        <p:spPr>
-          <a:xfrm>
-            <a:off x="1371600" y="4187952"/>
-            <a:ext cx="6309360" cy="457200"/>
-          </a:xfrm>
-          <a:prstGeom prst="rect">
-            <a:avLst/>
-          </a:prstGeom>
-          <a:noFill/>
-        </p:spPr>
-        <p:txBody>
-          <a:bodyPr wrap="square" anchor="ctr" lIns="0" rIns="0" tIns="0" bIns="0">
-            <a:spAutoFit/>
-          </a:bodyPr>
-          <a:lstStyle/>
-          <a:p>
-            <a:pPr algn="l">
-              <a:lnSpc>
-                <a:spcPct val="100000"/>
-              </a:lnSpc>
-              <a:spcBef>
-                <a:spcPts val="0"/>
-              </a:spcBef>
-              <a:spcAft>
-                <a:spcPts val="600"/>
-              </a:spcAft>
-            </a:pPr>
-            <a:r>
-              <a:rPr sz="1400" b="0">
-                <a:solidFill>
-                  <a:srgbClr val="0F172A"/>
-                </a:solidFill>
-                <a:latin typeface="NanumGothic"/>
-                <a:ea typeface="NanumGothic"/>
-                <a:cs typeface="NanumGothic"/>
-              </a:rPr>
-              <a:t>가설 제안 확정</a:t>
-            </a:r>
-          </a:p>
-        </p:txBody>
-      </p:sp>
-      <p:sp>
-        <p:nvSpPr>
-          <p:cNvPr id="23" name="Rounded Rectangle 22"/>
-          <p:cNvSpPr/>
-          <p:nvPr/>
-        </p:nvSpPr>
-        <p:spPr>
-          <a:xfrm>
-            <a:off x="8001000" y="1783080"/>
-            <a:ext cx="3657600" cy="4160520"/>
+            <a:off x="6172200" y="1828800"/>
+            <a:ext cx="5440680" cy="640080"/>
           </a:xfrm>
           <a:prstGeom prst="roundRect">
             <a:avLst/>
@@ -17278,22 +17549,22 @@
       </p:sp>
       <p:sp>
         <p:nvSpPr>
-          <p:cNvPr id="24" name="TextBox 23"/>
-          <p:cNvSpPr txBox="1"/>
-          <p:nvPr/>
-        </p:nvSpPr>
-        <p:spPr>
-          <a:xfrm>
-            <a:off x="8275320" y="2011680"/>
-            <a:ext cx="3108960" cy="457200"/>
-          </a:xfrm>
-          <a:prstGeom prst="rect">
-            <a:avLst/>
-          </a:prstGeom>
-          <a:noFill/>
-        </p:spPr>
-        <p:txBody>
-          <a:bodyPr wrap="square" anchor="t" lIns="0" rIns="0" tIns="0" bIns="0">
+          <p:cNvPr id="17" name="TextBox 16"/>
+          <p:cNvSpPr txBox="1"/>
+          <p:nvPr/>
+        </p:nvSpPr>
+        <p:spPr>
+          <a:xfrm>
+            <a:off x="6446520" y="1828800"/>
+            <a:ext cx="4937760" cy="640080"/>
+          </a:xfrm>
+          <a:prstGeom prst="rect">
+            <a:avLst/>
+          </a:prstGeom>
+          <a:noFill/>
+        </p:spPr>
+        <p:txBody>
+          <a:bodyPr wrap="square" anchor="ctr" lIns="0" rIns="0" tIns="0" bIns="0">
             <a:spAutoFit/>
           </a:bodyPr>
           <a:lstStyle/>
@@ -17310,29 +17581,29 @@
               </a:spcAft>
             </a:pPr>
             <a:r>
-              <a:rPr sz="1500" b="1">
-                <a:solidFill>
-                  <a:srgbClr val="F59E0B"/>
+              <a:rPr sz="1600" b="1">
+                <a:solidFill>
+                  <a:srgbClr val="FFFFFF"/>
                 </a:solidFill>
                 <a:latin typeface="NanumSquare"/>
                 <a:ea typeface="NanumSquare"/>
                 <a:cs typeface="NanumSquare"/>
               </a:rPr>
-              <a:t>산출물</a:t>
-            </a:r>
-          </a:p>
-        </p:txBody>
-      </p:sp>
-      <p:sp>
-        <p:nvSpPr>
-          <p:cNvPr id="25" name="TextBox 24"/>
-          <p:cNvSpPr txBox="1"/>
-          <p:nvPr/>
-        </p:nvSpPr>
-        <p:spPr>
-          <a:xfrm>
-            <a:off x="8275320" y="2560320"/>
-            <a:ext cx="3154680" cy="3108960"/>
+              <a:t>선별 (우선순위)</a:t>
+            </a:r>
+          </a:p>
+        </p:txBody>
+      </p:sp>
+      <p:sp>
+        <p:nvSpPr>
+          <p:cNvPr id="18" name="TextBox 17"/>
+          <p:cNvSpPr txBox="1"/>
+          <p:nvPr/>
+        </p:nvSpPr>
+        <p:spPr>
+          <a:xfrm>
+            <a:off x="6492240" y="2697480"/>
+            <a:ext cx="4846320" cy="548640"/>
           </a:xfrm>
           <a:prstGeom prst="rect">
             <a:avLst/>
@@ -17347,26 +17618,152 @@
           <a:p>
             <a:pPr algn="l">
               <a:lnSpc>
-                <a:spcPct val="120000"/>
-              </a:lnSpc>
-              <a:spcBef>
-                <a:spcPts val="0"/>
-              </a:spcBef>
-              <a:spcAft>
-                <a:spcPts val="600"/>
-              </a:spcAft>
-            </a:pPr>
-            <a:r>
-              <a:rPr sz="1400" b="0">
-                <a:solidFill>
-                  <a:srgbClr val="FFFFFF"/>
+                <a:spcPct val="100000"/>
+              </a:lnSpc>
+              <a:spcBef>
+                <a:spcPts val="0"/>
+              </a:spcBef>
+              <a:spcAft>
+                <a:spcPts val="600"/>
+              </a:spcAft>
+            </a:pPr>
+            <a:r>
+              <a:rPr sz="1400" b="1">
+                <a:solidFill>
+                  <a:srgbClr val="12203C"/>
                 </a:solidFill>
                 <a:latin typeface="NanumGothic"/>
                 <a:ea typeface="NanumGothic"/>
                 <a:cs typeface="NanumGothic"/>
               </a:rPr>
-              <a:t>최종 가설 제안 + 분석 노트
-에이전트 완주! 양식: output/report-template.md · 분석: result-analysis-template.md</a:t>
+              <a:t>•  </a:t>
+            </a:r>
+            <a:r>
+              <a:rPr sz="1400" b="0">
+                <a:solidFill>
+                  <a:srgbClr val="0F172A"/>
+                </a:solidFill>
+                <a:latin typeface="NanumGothic"/>
+                <a:ea typeface="NanumGothic"/>
+                <a:cs typeface="NanumGothic"/>
+              </a:rPr>
+              <a:t>근거·새로움·중요성</a:t>
+            </a:r>
+          </a:p>
+        </p:txBody>
+      </p:sp>
+      <p:sp>
+        <p:nvSpPr>
+          <p:cNvPr id="19" name="TextBox 18"/>
+          <p:cNvSpPr txBox="1"/>
+          <p:nvPr/>
+        </p:nvSpPr>
+        <p:spPr>
+          <a:xfrm>
+            <a:off x="6492240" y="3264408"/>
+            <a:ext cx="4846320" cy="548640"/>
+          </a:xfrm>
+          <a:prstGeom prst="rect">
+            <a:avLst/>
+          </a:prstGeom>
+          <a:noFill/>
+        </p:spPr>
+        <p:txBody>
+          <a:bodyPr wrap="square" anchor="t" lIns="0" rIns="0" tIns="0" bIns="0">
+            <a:spAutoFit/>
+          </a:bodyPr>
+          <a:lstStyle/>
+          <a:p>
+            <a:pPr algn="l">
+              <a:lnSpc>
+                <a:spcPct val="100000"/>
+              </a:lnSpc>
+              <a:spcBef>
+                <a:spcPts val="0"/>
+              </a:spcBef>
+              <a:spcAft>
+                <a:spcPts val="600"/>
+              </a:spcAft>
+            </a:pPr>
+            <a:r>
+              <a:rPr sz="1400" b="1">
+                <a:solidFill>
+                  <a:srgbClr val="12203C"/>
+                </a:solidFill>
+                <a:latin typeface="NanumGothic"/>
+                <a:ea typeface="NanumGothic"/>
+                <a:cs typeface="NanumGothic"/>
+              </a:rPr>
+              <a:t>•  </a:t>
+            </a:r>
+            <a:r>
+              <a:rPr sz="1400" b="0">
+                <a:solidFill>
+                  <a:srgbClr val="0F172A"/>
+                </a:solidFill>
+                <a:latin typeface="NanumGothic"/>
+                <a:ea typeface="NanumGothic"/>
+                <a:cs typeface="NanumGothic"/>
+              </a:rPr>
+              <a:t>검증 가능성</a:t>
+            </a:r>
+          </a:p>
+        </p:txBody>
+      </p:sp>
+      <p:sp>
+        <p:nvSpPr>
+          <p:cNvPr id="20" name="TextBox 19"/>
+          <p:cNvSpPr txBox="1"/>
+          <p:nvPr/>
+        </p:nvSpPr>
+        <p:spPr>
+          <a:xfrm>
+            <a:off x="6492240" y="3831336"/>
+            <a:ext cx="4846320" cy="548640"/>
+          </a:xfrm>
+          <a:prstGeom prst="rect">
+            <a:avLst/>
+          </a:prstGeom>
+          <a:noFill/>
+        </p:spPr>
+        <p:txBody>
+          <a:bodyPr wrap="square" anchor="t" lIns="0" rIns="0" tIns="0" bIns="0">
+            <a:spAutoFit/>
+          </a:bodyPr>
+          <a:lstStyle/>
+          <a:p>
+            <a:pPr algn="l">
+              <a:lnSpc>
+                <a:spcPct val="100000"/>
+              </a:lnSpc>
+              <a:spcBef>
+                <a:spcPts val="0"/>
+              </a:spcBef>
+              <a:spcAft>
+                <a:spcPts val="600"/>
+              </a:spcAft>
+            </a:pPr>
+            <a:r>
+              <a:rPr sz="1400" b="1">
+                <a:solidFill>
+                  <a:srgbClr val="12203C"/>
+                </a:solidFill>
+                <a:latin typeface="NanumGothic"/>
+                <a:ea typeface="NanumGothic"/>
+                <a:cs typeface="NanumGothic"/>
+              </a:rPr>
+              <a:t>•  </a:t>
+            </a:r>
+            <a:r>
+              <a:rPr sz="1400" b="0">
+                <a:solidFill>
+                  <a:srgbClr val="0F172A"/>
+                </a:solidFill>
+                <a:latin typeface="NanumGothic"/>
+                <a:ea typeface="NanumGothic"/>
+                <a:cs typeface="NanumGothic"/>
+              </a:rPr>
+              <a:t>상위 1~2개 추리기</a:t>
             </a:r>
           </a:p>
         </p:txBody>
@@ -17380,6 +17777,1984 @@
 </file>
 
 <file path=ppt/slides/slide24.xml><?xml version="1.0" encoding="utf-8"?>
+<p:sld xmlns:a="http://schemas.openxmlformats.org/drawingml/2006/main" xmlns:p="http://schemas.openxmlformats.org/presentationml/2006/main" xmlns:r="http://schemas.openxmlformats.org/officeDocument/2006/relationships">
+  <p:cSld>
+    <p:spTree>
+      <p:nvGrpSpPr>
+        <p:cNvPr id="1" name=""/>
+        <p:cNvGrpSpPr/>
+        <p:nvPr/>
+      </p:nvGrpSpPr>
+      <p:grpSpPr/>
+      <p:sp>
+        <p:nvSpPr>
+          <p:cNvPr id="2" name="Rectangle 1"/>
+          <p:cNvSpPr/>
+          <p:nvPr/>
+        </p:nvSpPr>
+        <p:spPr>
+          <a:xfrm>
+            <a:off x="0" y="0"/>
+            <a:ext cx="12191695" cy="6858000"/>
+          </a:xfrm>
+          <a:prstGeom prst="rect">
+            <a:avLst/>
+          </a:prstGeom>
+          <a:solidFill>
+            <a:srgbClr val="FFFFFF"/>
+          </a:solidFill>
+          <a:ln>
+            <a:noFill/>
+          </a:ln>
+          <a:effectLst/>
+        </p:spPr>
+        <p:style>
+          <a:lnRef idx="1">
+            <a:schemeClr val="accent1"/>
+          </a:lnRef>
+          <a:fillRef idx="3">
+            <a:schemeClr val="accent1"/>
+          </a:fillRef>
+          <a:effectRef idx="2">
+            <a:schemeClr val="accent1"/>
+          </a:effectRef>
+          <a:fontRef idx="minor">
+            <a:schemeClr val="lt1"/>
+          </a:fontRef>
+        </p:style>
+        <p:txBody>
+          <a:bodyPr rtlCol="0" anchor="ctr"/>
+          <a:lstStyle/>
+          <a:p>
+            <a:pPr algn="ctr"/>
+          </a:p>
+        </p:txBody>
+      </p:sp>
+      <p:sp>
+        <p:nvSpPr>
+          <p:cNvPr id="3" name="Rectangle 2"/>
+          <p:cNvSpPr/>
+          <p:nvPr/>
+        </p:nvSpPr>
+        <p:spPr>
+          <a:xfrm>
+            <a:off x="0" y="0"/>
+            <a:ext cx="164592" cy="6858000"/>
+          </a:xfrm>
+          <a:prstGeom prst="rect">
+            <a:avLst/>
+          </a:prstGeom>
+          <a:solidFill>
+            <a:srgbClr val="F59E0B"/>
+          </a:solidFill>
+          <a:ln>
+            <a:noFill/>
+          </a:ln>
+          <a:effectLst/>
+        </p:spPr>
+        <p:style>
+          <a:lnRef idx="1">
+            <a:schemeClr val="accent1"/>
+          </a:lnRef>
+          <a:fillRef idx="3">
+            <a:schemeClr val="accent1"/>
+          </a:fillRef>
+          <a:effectRef idx="2">
+            <a:schemeClr val="accent1"/>
+          </a:effectRef>
+          <a:fontRef idx="minor">
+            <a:schemeClr val="lt1"/>
+          </a:fontRef>
+        </p:style>
+        <p:txBody>
+          <a:bodyPr rtlCol="0" anchor="ctr"/>
+          <a:lstStyle/>
+          <a:p>
+            <a:pPr algn="ctr"/>
+          </a:p>
+        </p:txBody>
+      </p:sp>
+      <p:sp>
+        <p:nvSpPr>
+          <p:cNvPr id="4" name="TextBox 3"/>
+          <p:cNvSpPr txBox="1"/>
+          <p:nvPr/>
+        </p:nvSpPr>
+        <p:spPr>
+          <a:xfrm>
+            <a:off x="502920" y="384048"/>
+            <a:ext cx="10058400" cy="320040"/>
+          </a:xfrm>
+          <a:prstGeom prst="rect">
+            <a:avLst/>
+          </a:prstGeom>
+          <a:noFill/>
+        </p:spPr>
+        <p:txBody>
+          <a:bodyPr wrap="square" anchor="t" lIns="0" rIns="0" tIns="0" bIns="0">
+            <a:spAutoFit/>
+          </a:bodyPr>
+          <a:lstStyle/>
+          <a:p>
+            <a:pPr algn="l">
+              <a:lnSpc>
+                <a:spcPct val="100000"/>
+              </a:lnSpc>
+              <a:spcBef>
+                <a:spcPts val="0"/>
+              </a:spcBef>
+              <a:spcAft>
+                <a:spcPts val="600"/>
+              </a:spcAft>
+            </a:pPr>
+            <a:r>
+              <a:rPr sz="1200" b="1">
+                <a:solidFill>
+                  <a:srgbClr val="F59E0B"/>
+                </a:solidFill>
+                <a:latin typeface="NanumGothic"/>
+                <a:ea typeface="NanumGothic"/>
+                <a:cs typeface="NanumGothic"/>
+              </a:rPr>
+              <a:t>점검</a:t>
+            </a:r>
+          </a:p>
+        </p:txBody>
+      </p:sp>
+      <p:sp>
+        <p:nvSpPr>
+          <p:cNvPr id="5" name="TextBox 4"/>
+          <p:cNvSpPr txBox="1"/>
+          <p:nvPr/>
+        </p:nvSpPr>
+        <p:spPr>
+          <a:xfrm>
+            <a:off x="502920" y="713232"/>
+            <a:ext cx="11155680" cy="731520"/>
+          </a:xfrm>
+          <a:prstGeom prst="rect">
+            <a:avLst/>
+          </a:prstGeom>
+          <a:noFill/>
+        </p:spPr>
+        <p:txBody>
+          <a:bodyPr wrap="square" anchor="t" lIns="0" rIns="0" tIns="0" bIns="0">
+            <a:spAutoFit/>
+          </a:bodyPr>
+          <a:lstStyle/>
+          <a:p>
+            <a:pPr algn="l">
+              <a:lnSpc>
+                <a:spcPct val="100000"/>
+              </a:lnSpc>
+              <a:spcBef>
+                <a:spcPts val="0"/>
+              </a:spcBef>
+              <a:spcAft>
+                <a:spcPts val="600"/>
+              </a:spcAft>
+            </a:pPr>
+            <a:r>
+              <a:rPr sz="2700" b="1">
+                <a:solidFill>
+                  <a:srgbClr val="0F172A"/>
+                </a:solidFill>
+                <a:latin typeface="NanumSquare"/>
+                <a:ea typeface="NanumSquare"/>
+                <a:cs typeface="NanumSquare"/>
+              </a:rPr>
+              <a:t>제안 전 마지막 점검</a:t>
+            </a:r>
+          </a:p>
+        </p:txBody>
+      </p:sp>
+      <p:sp>
+        <p:nvSpPr>
+          <p:cNvPr id="6" name="Rectangle 5"/>
+          <p:cNvSpPr/>
+          <p:nvPr/>
+        </p:nvSpPr>
+        <p:spPr>
+          <a:xfrm>
+            <a:off x="521207" y="1417320"/>
+            <a:ext cx="1005840" cy="45720"/>
+          </a:xfrm>
+          <a:prstGeom prst="rect">
+            <a:avLst/>
+          </a:prstGeom>
+          <a:solidFill>
+            <a:srgbClr val="F59E0B"/>
+          </a:solidFill>
+          <a:ln>
+            <a:noFill/>
+          </a:ln>
+          <a:effectLst/>
+        </p:spPr>
+        <p:style>
+          <a:lnRef idx="1">
+            <a:schemeClr val="accent1"/>
+          </a:lnRef>
+          <a:fillRef idx="3">
+            <a:schemeClr val="accent1"/>
+          </a:fillRef>
+          <a:effectRef idx="2">
+            <a:schemeClr val="accent1"/>
+          </a:effectRef>
+          <a:fontRef idx="minor">
+            <a:schemeClr val="lt1"/>
+          </a:fontRef>
+        </p:style>
+        <p:txBody>
+          <a:bodyPr rtlCol="0" anchor="ctr"/>
+          <a:lstStyle/>
+          <a:p>
+            <a:pPr algn="ctr"/>
+          </a:p>
+        </p:txBody>
+      </p:sp>
+      <p:sp>
+        <p:nvSpPr>
+          <p:cNvPr id="7" name="TextBox 6"/>
+          <p:cNvSpPr txBox="1"/>
+          <p:nvPr/>
+        </p:nvSpPr>
+        <p:spPr>
+          <a:xfrm>
+            <a:off x="502920" y="6419088"/>
+            <a:ext cx="7315200" cy="365760"/>
+          </a:xfrm>
+          <a:prstGeom prst="rect">
+            <a:avLst/>
+          </a:prstGeom>
+          <a:noFill/>
+        </p:spPr>
+        <p:txBody>
+          <a:bodyPr wrap="square" anchor="ctr" lIns="0" rIns="0" tIns="0" bIns="0">
+            <a:spAutoFit/>
+          </a:bodyPr>
+          <a:lstStyle/>
+          <a:p>
+            <a:pPr algn="l">
+              <a:lnSpc>
+                <a:spcPct val="100000"/>
+              </a:lnSpc>
+              <a:spcBef>
+                <a:spcPts val="0"/>
+              </a:spcBef>
+              <a:spcAft>
+                <a:spcPts val="600"/>
+              </a:spcAft>
+            </a:pPr>
+            <a:r>
+              <a:rPr sz="900" b="0">
+                <a:solidFill>
+                  <a:srgbClr val="64748B"/>
+                </a:solidFill>
+                <a:latin typeface="NanumGothic"/>
+                <a:ea typeface="NanumGothic"/>
+                <a:cs typeface="NanumGothic"/>
+              </a:rPr>
+              <a:t>AI 에이전트와 응용  ·  원광대학교 5일 교육</a:t>
+            </a:r>
+          </a:p>
+        </p:txBody>
+      </p:sp>
+      <p:sp>
+        <p:nvSpPr>
+          <p:cNvPr id="8" name="TextBox 7"/>
+          <p:cNvSpPr txBox="1"/>
+          <p:nvPr/>
+        </p:nvSpPr>
+        <p:spPr>
+          <a:xfrm>
+            <a:off x="10241280" y="6419088"/>
+            <a:ext cx="1463040" cy="365760"/>
+          </a:xfrm>
+          <a:prstGeom prst="rect">
+            <a:avLst/>
+          </a:prstGeom>
+          <a:noFill/>
+        </p:spPr>
+        <p:txBody>
+          <a:bodyPr wrap="square" anchor="ctr" lIns="0" rIns="0" tIns="0" bIns="0">
+            <a:spAutoFit/>
+          </a:bodyPr>
+          <a:lstStyle/>
+          <a:p>
+            <a:pPr algn="r">
+              <a:lnSpc>
+                <a:spcPct val="100000"/>
+              </a:lnSpc>
+              <a:spcBef>
+                <a:spcPts val="0"/>
+              </a:spcBef>
+              <a:spcAft>
+                <a:spcPts val="600"/>
+              </a:spcAft>
+            </a:pPr>
+            <a:r>
+              <a:rPr sz="900" b="1">
+                <a:solidFill>
+                  <a:srgbClr val="F59E0B"/>
+                </a:solidFill>
+                <a:latin typeface="NanumGothic"/>
+                <a:ea typeface="NanumGothic"/>
+                <a:cs typeface="NanumGothic"/>
+              </a:rPr>
+              <a:t>Day 4 · 목</a:t>
+            </a:r>
+          </a:p>
+        </p:txBody>
+      </p:sp>
+      <p:sp>
+        <p:nvSpPr>
+          <p:cNvPr id="9" name="Oval 8"/>
+          <p:cNvSpPr/>
+          <p:nvPr/>
+        </p:nvSpPr>
+        <p:spPr>
+          <a:xfrm>
+            <a:off x="548640" y="1911096"/>
+            <a:ext cx="146304" cy="146304"/>
+          </a:xfrm>
+          <a:prstGeom prst="ellipse">
+            <a:avLst/>
+          </a:prstGeom>
+          <a:solidFill>
+            <a:srgbClr val="F59E0B"/>
+          </a:solidFill>
+          <a:ln>
+            <a:noFill/>
+          </a:ln>
+          <a:effectLst/>
+        </p:spPr>
+        <p:style>
+          <a:lnRef idx="1">
+            <a:schemeClr val="accent1"/>
+          </a:lnRef>
+          <a:fillRef idx="3">
+            <a:schemeClr val="accent1"/>
+          </a:fillRef>
+          <a:effectRef idx="2">
+            <a:schemeClr val="accent1"/>
+          </a:effectRef>
+          <a:fontRef idx="minor">
+            <a:schemeClr val="lt1"/>
+          </a:fontRef>
+        </p:style>
+        <p:txBody>
+          <a:bodyPr rtlCol="0" anchor="ctr"/>
+          <a:lstStyle/>
+          <a:p>
+            <a:pPr algn="ctr"/>
+          </a:p>
+        </p:txBody>
+      </p:sp>
+      <p:sp>
+        <p:nvSpPr>
+          <p:cNvPr id="10" name="TextBox 9"/>
+          <p:cNvSpPr txBox="1"/>
+          <p:nvPr/>
+        </p:nvSpPr>
+        <p:spPr>
+          <a:xfrm>
+            <a:off x="868680" y="1828800"/>
+            <a:ext cx="10607040" cy="457200"/>
+          </a:xfrm>
+          <a:prstGeom prst="rect">
+            <a:avLst/>
+          </a:prstGeom>
+          <a:noFill/>
+        </p:spPr>
+        <p:txBody>
+          <a:bodyPr wrap="square" anchor="t" lIns="0" rIns="0" tIns="0" bIns="0">
+            <a:spAutoFit/>
+          </a:bodyPr>
+          <a:lstStyle/>
+          <a:p>
+            <a:pPr algn="l">
+              <a:lnSpc>
+                <a:spcPct val="100000"/>
+              </a:lnSpc>
+              <a:spcBef>
+                <a:spcPts val="0"/>
+              </a:spcBef>
+              <a:spcAft>
+                <a:spcPts val="600"/>
+              </a:spcAft>
+            </a:pPr>
+            <a:r>
+              <a:rPr sz="1600" b="1">
+                <a:solidFill>
+                  <a:srgbClr val="0F172A"/>
+                </a:solidFill>
+                <a:latin typeface="NanumGothic"/>
+                <a:ea typeface="NanumGothic"/>
+                <a:cs typeface="NanumGothic"/>
+              </a:rPr>
+              <a:t>근거 있나?</a:t>
+            </a:r>
+          </a:p>
+        </p:txBody>
+      </p:sp>
+      <p:sp>
+        <p:nvSpPr>
+          <p:cNvPr id="11" name="TextBox 10"/>
+          <p:cNvSpPr txBox="1"/>
+          <p:nvPr/>
+        </p:nvSpPr>
+        <p:spPr>
+          <a:xfrm>
+            <a:off x="868680" y="2212848"/>
+            <a:ext cx="10607040" cy="457200"/>
+          </a:xfrm>
+          <a:prstGeom prst="rect">
+            <a:avLst/>
+          </a:prstGeom>
+          <a:noFill/>
+        </p:spPr>
+        <p:txBody>
+          <a:bodyPr wrap="square" anchor="t" lIns="0" rIns="0" tIns="0" bIns="0">
+            <a:spAutoFit/>
+          </a:bodyPr>
+          <a:lstStyle/>
+          <a:p>
+            <a:pPr algn="l">
+              <a:lnSpc>
+                <a:spcPct val="100000"/>
+              </a:lnSpc>
+              <a:spcBef>
+                <a:spcPts val="0"/>
+              </a:spcBef>
+              <a:spcAft>
+                <a:spcPts val="600"/>
+              </a:spcAft>
+            </a:pPr>
+            <a:r>
+              <a:rPr sz="1300" b="0">
+                <a:solidFill>
+                  <a:srgbClr val="64748B"/>
+                </a:solidFill>
+                <a:latin typeface="NanumGothic"/>
+                <a:ea typeface="NanumGothic"/>
+                <a:cs typeface="NanumGothic"/>
+              </a:rPr>
+              <a:t>막연한 상상 아닌, gap·출처 기반</a:t>
+            </a:r>
+          </a:p>
+        </p:txBody>
+      </p:sp>
+      <p:sp>
+        <p:nvSpPr>
+          <p:cNvPr id="12" name="Oval 11"/>
+          <p:cNvSpPr/>
+          <p:nvPr/>
+        </p:nvSpPr>
+        <p:spPr>
+          <a:xfrm>
+            <a:off x="548640" y="2779776"/>
+            <a:ext cx="146304" cy="146304"/>
+          </a:xfrm>
+          <a:prstGeom prst="ellipse">
+            <a:avLst/>
+          </a:prstGeom>
+          <a:solidFill>
+            <a:srgbClr val="F59E0B"/>
+          </a:solidFill>
+          <a:ln>
+            <a:noFill/>
+          </a:ln>
+          <a:effectLst/>
+        </p:spPr>
+        <p:style>
+          <a:lnRef idx="1">
+            <a:schemeClr val="accent1"/>
+          </a:lnRef>
+          <a:fillRef idx="3">
+            <a:schemeClr val="accent1"/>
+          </a:fillRef>
+          <a:effectRef idx="2">
+            <a:schemeClr val="accent1"/>
+          </a:effectRef>
+          <a:fontRef idx="minor">
+            <a:schemeClr val="lt1"/>
+          </a:fontRef>
+        </p:style>
+        <p:txBody>
+          <a:bodyPr rtlCol="0" anchor="ctr"/>
+          <a:lstStyle/>
+          <a:p>
+            <a:pPr algn="ctr"/>
+          </a:p>
+        </p:txBody>
+      </p:sp>
+      <p:sp>
+        <p:nvSpPr>
+          <p:cNvPr id="13" name="TextBox 12"/>
+          <p:cNvSpPr txBox="1"/>
+          <p:nvPr/>
+        </p:nvSpPr>
+        <p:spPr>
+          <a:xfrm>
+            <a:off x="868680" y="2697480"/>
+            <a:ext cx="10607040" cy="457200"/>
+          </a:xfrm>
+          <a:prstGeom prst="rect">
+            <a:avLst/>
+          </a:prstGeom>
+          <a:noFill/>
+        </p:spPr>
+        <p:txBody>
+          <a:bodyPr wrap="square" anchor="t" lIns="0" rIns="0" tIns="0" bIns="0">
+            <a:spAutoFit/>
+          </a:bodyPr>
+          <a:lstStyle/>
+          <a:p>
+            <a:pPr algn="l">
+              <a:lnSpc>
+                <a:spcPct val="100000"/>
+              </a:lnSpc>
+              <a:spcBef>
+                <a:spcPts val="0"/>
+              </a:spcBef>
+              <a:spcAft>
+                <a:spcPts val="600"/>
+              </a:spcAft>
+            </a:pPr>
+            <a:r>
+              <a:rPr sz="1600" b="1">
+                <a:solidFill>
+                  <a:srgbClr val="0F172A"/>
+                </a:solidFill>
+                <a:latin typeface="NanumGothic"/>
+                <a:ea typeface="NanumGothic"/>
+                <a:cs typeface="NanumGothic"/>
+              </a:rPr>
+              <a:t>새로운가?</a:t>
+            </a:r>
+          </a:p>
+        </p:txBody>
+      </p:sp>
+      <p:sp>
+        <p:nvSpPr>
+          <p:cNvPr id="14" name="TextBox 13"/>
+          <p:cNvSpPr txBox="1"/>
+          <p:nvPr/>
+        </p:nvSpPr>
+        <p:spPr>
+          <a:xfrm>
+            <a:off x="868680" y="3081528"/>
+            <a:ext cx="10607040" cy="457200"/>
+          </a:xfrm>
+          <a:prstGeom prst="rect">
+            <a:avLst/>
+          </a:prstGeom>
+          <a:noFill/>
+        </p:spPr>
+        <p:txBody>
+          <a:bodyPr wrap="square" anchor="t" lIns="0" rIns="0" tIns="0" bIns="0">
+            <a:spAutoFit/>
+          </a:bodyPr>
+          <a:lstStyle/>
+          <a:p>
+            <a:pPr algn="l">
+              <a:lnSpc>
+                <a:spcPct val="100000"/>
+              </a:lnSpc>
+              <a:spcBef>
+                <a:spcPts val="0"/>
+              </a:spcBef>
+              <a:spcAft>
+                <a:spcPts val="600"/>
+              </a:spcAft>
+            </a:pPr>
+            <a:r>
+              <a:rPr sz="1300" b="0">
+                <a:solidFill>
+                  <a:srgbClr val="64748B"/>
+                </a:solidFill>
+                <a:latin typeface="NanumGothic"/>
+                <a:ea typeface="NanumGothic"/>
+                <a:cs typeface="NanumGothic"/>
+              </a:rPr>
+              <a:t>기존 논문에 이미 있는 건 아닌지</a:t>
+            </a:r>
+          </a:p>
+        </p:txBody>
+      </p:sp>
+      <p:sp>
+        <p:nvSpPr>
+          <p:cNvPr id="15" name="Oval 14"/>
+          <p:cNvSpPr/>
+          <p:nvPr/>
+        </p:nvSpPr>
+        <p:spPr>
+          <a:xfrm>
+            <a:off x="548640" y="3648456"/>
+            <a:ext cx="146304" cy="146304"/>
+          </a:xfrm>
+          <a:prstGeom prst="ellipse">
+            <a:avLst/>
+          </a:prstGeom>
+          <a:solidFill>
+            <a:srgbClr val="F59E0B"/>
+          </a:solidFill>
+          <a:ln>
+            <a:noFill/>
+          </a:ln>
+          <a:effectLst/>
+        </p:spPr>
+        <p:style>
+          <a:lnRef idx="1">
+            <a:schemeClr val="accent1"/>
+          </a:lnRef>
+          <a:fillRef idx="3">
+            <a:schemeClr val="accent1"/>
+          </a:fillRef>
+          <a:effectRef idx="2">
+            <a:schemeClr val="accent1"/>
+          </a:effectRef>
+          <a:fontRef idx="minor">
+            <a:schemeClr val="lt1"/>
+          </a:fontRef>
+        </p:style>
+        <p:txBody>
+          <a:bodyPr rtlCol="0" anchor="ctr"/>
+          <a:lstStyle/>
+          <a:p>
+            <a:pPr algn="ctr"/>
+          </a:p>
+        </p:txBody>
+      </p:sp>
+      <p:sp>
+        <p:nvSpPr>
+          <p:cNvPr id="16" name="TextBox 15"/>
+          <p:cNvSpPr txBox="1"/>
+          <p:nvPr/>
+        </p:nvSpPr>
+        <p:spPr>
+          <a:xfrm>
+            <a:off x="868680" y="3566160"/>
+            <a:ext cx="10607040" cy="457200"/>
+          </a:xfrm>
+          <a:prstGeom prst="rect">
+            <a:avLst/>
+          </a:prstGeom>
+          <a:noFill/>
+        </p:spPr>
+        <p:txBody>
+          <a:bodyPr wrap="square" anchor="t" lIns="0" rIns="0" tIns="0" bIns="0">
+            <a:spAutoFit/>
+          </a:bodyPr>
+          <a:lstStyle/>
+          <a:p>
+            <a:pPr algn="l">
+              <a:lnSpc>
+                <a:spcPct val="100000"/>
+              </a:lnSpc>
+              <a:spcBef>
+                <a:spcPts val="0"/>
+              </a:spcBef>
+              <a:spcAft>
+                <a:spcPts val="600"/>
+              </a:spcAft>
+            </a:pPr>
+            <a:r>
+              <a:rPr sz="1600" b="1">
+                <a:solidFill>
+                  <a:srgbClr val="0F172A"/>
+                </a:solidFill>
+                <a:latin typeface="NanumGothic"/>
+                <a:ea typeface="NanumGothic"/>
+                <a:cs typeface="NanumGothic"/>
+              </a:rPr>
+              <a:t>검증 아이디어 있나?</a:t>
+            </a:r>
+          </a:p>
+        </p:txBody>
+      </p:sp>
+      <p:sp>
+        <p:nvSpPr>
+          <p:cNvPr id="17" name="TextBox 16"/>
+          <p:cNvSpPr txBox="1"/>
+          <p:nvPr/>
+        </p:nvSpPr>
+        <p:spPr>
+          <a:xfrm>
+            <a:off x="868680" y="3950208"/>
+            <a:ext cx="10607040" cy="457200"/>
+          </a:xfrm>
+          <a:prstGeom prst="rect">
+            <a:avLst/>
+          </a:prstGeom>
+          <a:noFill/>
+        </p:spPr>
+        <p:txBody>
+          <a:bodyPr wrap="square" anchor="t" lIns="0" rIns="0" tIns="0" bIns="0">
+            <a:spAutoFit/>
+          </a:bodyPr>
+          <a:lstStyle/>
+          <a:p>
+            <a:pPr algn="l">
+              <a:lnSpc>
+                <a:spcPct val="100000"/>
+              </a:lnSpc>
+              <a:spcBef>
+                <a:spcPts val="0"/>
+              </a:spcBef>
+              <a:spcAft>
+                <a:spcPts val="600"/>
+              </a:spcAft>
+            </a:pPr>
+            <a:r>
+              <a:rPr sz="1300" b="0">
+                <a:solidFill>
+                  <a:srgbClr val="64748B"/>
+                </a:solidFill>
+                <a:latin typeface="NanumGothic"/>
+                <a:ea typeface="NanumGothic"/>
+                <a:cs typeface="NanumGothic"/>
+              </a:rPr>
+              <a:t>어떻게 확인할지 한 줄이라도</a:t>
+            </a:r>
+          </a:p>
+        </p:txBody>
+      </p:sp>
+      <p:sp>
+        <p:nvSpPr>
+          <p:cNvPr id="18" name="Rounded Rectangle 17"/>
+          <p:cNvSpPr/>
+          <p:nvPr/>
+        </p:nvSpPr>
+        <p:spPr>
+          <a:xfrm>
+            <a:off x="502920" y="5532120"/>
+            <a:ext cx="11155680" cy="658368"/>
+          </a:xfrm>
+          <a:prstGeom prst="roundRect">
+            <a:avLst/>
+          </a:prstGeom>
+          <a:solidFill>
+            <a:srgbClr val="F1F5F9"/>
+          </a:solidFill>
+          <a:ln w="12700">
+            <a:solidFill>
+              <a:srgbClr val="E2E8F0"/>
+            </a:solidFill>
+          </a:ln>
+          <a:effectLst/>
+        </p:spPr>
+        <p:style>
+          <a:lnRef idx="1">
+            <a:schemeClr val="accent1"/>
+          </a:lnRef>
+          <a:fillRef idx="3">
+            <a:schemeClr val="accent1"/>
+          </a:fillRef>
+          <a:effectRef idx="2">
+            <a:schemeClr val="accent1"/>
+          </a:effectRef>
+          <a:fontRef idx="minor">
+            <a:schemeClr val="lt1"/>
+          </a:fontRef>
+        </p:style>
+        <p:txBody>
+          <a:bodyPr rtlCol="0" anchor="ctr"/>
+          <a:lstStyle/>
+          <a:p>
+            <a:pPr algn="ctr"/>
+          </a:p>
+        </p:txBody>
+      </p:sp>
+      <p:sp>
+        <p:nvSpPr>
+          <p:cNvPr id="19" name="TextBox 18"/>
+          <p:cNvSpPr txBox="1"/>
+          <p:nvPr/>
+        </p:nvSpPr>
+        <p:spPr>
+          <a:xfrm>
+            <a:off x="777240" y="5532120"/>
+            <a:ext cx="10607040" cy="658368"/>
+          </a:xfrm>
+          <a:prstGeom prst="rect">
+            <a:avLst/>
+          </a:prstGeom>
+          <a:noFill/>
+        </p:spPr>
+        <p:txBody>
+          <a:bodyPr wrap="square" anchor="ctr" lIns="0" rIns="0" tIns="0" bIns="0">
+            <a:spAutoFit/>
+          </a:bodyPr>
+          <a:lstStyle/>
+          <a:p>
+            <a:pPr algn="l">
+              <a:lnSpc>
+                <a:spcPct val="100000"/>
+              </a:lnSpc>
+              <a:spcBef>
+                <a:spcPts val="0"/>
+              </a:spcBef>
+              <a:spcAft>
+                <a:spcPts val="600"/>
+              </a:spcAft>
+            </a:pPr>
+            <a:r>
+              <a:rPr sz="1200" b="1">
+                <a:solidFill>
+                  <a:srgbClr val="F59E0B"/>
+                </a:solidFill>
+                <a:latin typeface="NanumGothic"/>
+                <a:ea typeface="NanumGothic"/>
+                <a:cs typeface="NanumGothic"/>
+              </a:rPr>
+              <a:t>NOTE   </a:t>
+            </a:r>
+            <a:r>
+              <a:rPr sz="1300" b="0">
+                <a:solidFill>
+                  <a:srgbClr val="0F172A"/>
+                </a:solidFill>
+                <a:latin typeface="NanumGothic"/>
+                <a:ea typeface="NanumGothic"/>
+                <a:cs typeface="NanumGothic"/>
+              </a:rPr>
+              <a:t>약하면 되돌아가 재생성·보강 (iteration)</a:t>
+            </a:r>
+          </a:p>
+        </p:txBody>
+      </p:sp>
+    </p:spTree>
+  </p:cSld>
+  <p:clrMapOvr>
+    <a:masterClrMapping/>
+  </p:clrMapOvr>
+</p:sld>
+</file>
+
+<file path=ppt/slides/slide25.xml><?xml version="1.0" encoding="utf-8"?>
+<p:sld xmlns:a="http://schemas.openxmlformats.org/drawingml/2006/main" xmlns:p="http://schemas.openxmlformats.org/presentationml/2006/main" xmlns:r="http://schemas.openxmlformats.org/officeDocument/2006/relationships">
+  <p:cSld>
+    <p:spTree>
+      <p:nvGrpSpPr>
+        <p:cNvPr id="1" name=""/>
+        <p:cNvGrpSpPr/>
+        <p:nvPr/>
+      </p:nvGrpSpPr>
+      <p:grpSpPr/>
+      <p:sp>
+        <p:nvSpPr>
+          <p:cNvPr id="2" name="Rectangle 1"/>
+          <p:cNvSpPr/>
+          <p:nvPr/>
+        </p:nvSpPr>
+        <p:spPr>
+          <a:xfrm>
+            <a:off x="0" y="0"/>
+            <a:ext cx="12191695" cy="6858000"/>
+          </a:xfrm>
+          <a:prstGeom prst="rect">
+            <a:avLst/>
+          </a:prstGeom>
+          <a:solidFill>
+            <a:srgbClr val="FFFFFF"/>
+          </a:solidFill>
+          <a:ln>
+            <a:noFill/>
+          </a:ln>
+          <a:effectLst/>
+        </p:spPr>
+        <p:style>
+          <a:lnRef idx="1">
+            <a:schemeClr val="accent1"/>
+          </a:lnRef>
+          <a:fillRef idx="3">
+            <a:schemeClr val="accent1"/>
+          </a:fillRef>
+          <a:effectRef idx="2">
+            <a:schemeClr val="accent1"/>
+          </a:effectRef>
+          <a:fontRef idx="minor">
+            <a:schemeClr val="lt1"/>
+          </a:fontRef>
+        </p:style>
+        <p:txBody>
+          <a:bodyPr rtlCol="0" anchor="ctr"/>
+          <a:lstStyle/>
+          <a:p>
+            <a:pPr algn="ctr"/>
+          </a:p>
+        </p:txBody>
+      </p:sp>
+      <p:sp>
+        <p:nvSpPr>
+          <p:cNvPr id="3" name="Rectangle 2"/>
+          <p:cNvSpPr/>
+          <p:nvPr/>
+        </p:nvSpPr>
+        <p:spPr>
+          <a:xfrm>
+            <a:off x="0" y="0"/>
+            <a:ext cx="164592" cy="6858000"/>
+          </a:xfrm>
+          <a:prstGeom prst="rect">
+            <a:avLst/>
+          </a:prstGeom>
+          <a:solidFill>
+            <a:srgbClr val="F59E0B"/>
+          </a:solidFill>
+          <a:ln>
+            <a:noFill/>
+          </a:ln>
+          <a:effectLst/>
+        </p:spPr>
+        <p:style>
+          <a:lnRef idx="1">
+            <a:schemeClr val="accent1"/>
+          </a:lnRef>
+          <a:fillRef idx="3">
+            <a:schemeClr val="accent1"/>
+          </a:fillRef>
+          <a:effectRef idx="2">
+            <a:schemeClr val="accent1"/>
+          </a:effectRef>
+          <a:fontRef idx="minor">
+            <a:schemeClr val="lt1"/>
+          </a:fontRef>
+        </p:style>
+        <p:txBody>
+          <a:bodyPr rtlCol="0" anchor="ctr"/>
+          <a:lstStyle/>
+          <a:p>
+            <a:pPr algn="ctr"/>
+          </a:p>
+        </p:txBody>
+      </p:sp>
+      <p:sp>
+        <p:nvSpPr>
+          <p:cNvPr id="4" name="TextBox 3"/>
+          <p:cNvSpPr txBox="1"/>
+          <p:nvPr/>
+        </p:nvSpPr>
+        <p:spPr>
+          <a:xfrm>
+            <a:off x="502920" y="384048"/>
+            <a:ext cx="10058400" cy="320040"/>
+          </a:xfrm>
+          <a:prstGeom prst="rect">
+            <a:avLst/>
+          </a:prstGeom>
+          <a:noFill/>
+        </p:spPr>
+        <p:txBody>
+          <a:bodyPr wrap="square" anchor="t" lIns="0" rIns="0" tIns="0" bIns="0">
+            <a:spAutoFit/>
+          </a:bodyPr>
+          <a:lstStyle/>
+          <a:p>
+            <a:pPr algn="l">
+              <a:lnSpc>
+                <a:spcPct val="100000"/>
+              </a:lnSpc>
+              <a:spcBef>
+                <a:spcPts val="0"/>
+              </a:spcBef>
+              <a:spcAft>
+                <a:spcPts val="600"/>
+              </a:spcAft>
+            </a:pPr>
+            <a:r>
+              <a:rPr sz="1200" b="1">
+                <a:solidFill>
+                  <a:srgbClr val="F59E0B"/>
+                </a:solidFill>
+                <a:latin typeface="NanumGothic"/>
+                <a:ea typeface="NanumGothic"/>
+                <a:cs typeface="NanumGothic"/>
+              </a:rPr>
+              <a:t>LAB · 실습</a:t>
+            </a:r>
+          </a:p>
+        </p:txBody>
+      </p:sp>
+      <p:sp>
+        <p:nvSpPr>
+          <p:cNvPr id="5" name="TextBox 4"/>
+          <p:cNvSpPr txBox="1"/>
+          <p:nvPr/>
+        </p:nvSpPr>
+        <p:spPr>
+          <a:xfrm>
+            <a:off x="502920" y="713232"/>
+            <a:ext cx="11155680" cy="731520"/>
+          </a:xfrm>
+          <a:prstGeom prst="rect">
+            <a:avLst/>
+          </a:prstGeom>
+          <a:noFill/>
+        </p:spPr>
+        <p:txBody>
+          <a:bodyPr wrap="square" anchor="t" lIns="0" rIns="0" tIns="0" bIns="0">
+            <a:spAutoFit/>
+          </a:bodyPr>
+          <a:lstStyle/>
+          <a:p>
+            <a:pPr algn="l">
+              <a:lnSpc>
+                <a:spcPct val="100000"/>
+              </a:lnSpc>
+              <a:spcBef>
+                <a:spcPts val="0"/>
+              </a:spcBef>
+              <a:spcAft>
+                <a:spcPts val="600"/>
+              </a:spcAft>
+            </a:pPr>
+            <a:r>
+              <a:rPr sz="2700" b="1">
+                <a:solidFill>
+                  <a:srgbClr val="0F172A"/>
+                </a:solidFill>
+                <a:latin typeface="NanumSquare"/>
+                <a:ea typeface="NanumSquare"/>
+                <a:cs typeface="NanumSquare"/>
+              </a:rPr>
+              <a:t>가설 생성·평가 → 제안 확정</a:t>
+            </a:r>
+          </a:p>
+        </p:txBody>
+      </p:sp>
+      <p:sp>
+        <p:nvSpPr>
+          <p:cNvPr id="6" name="Rectangle 5"/>
+          <p:cNvSpPr/>
+          <p:nvPr/>
+        </p:nvSpPr>
+        <p:spPr>
+          <a:xfrm>
+            <a:off x="521207" y="1417320"/>
+            <a:ext cx="1005840" cy="45720"/>
+          </a:xfrm>
+          <a:prstGeom prst="rect">
+            <a:avLst/>
+          </a:prstGeom>
+          <a:solidFill>
+            <a:srgbClr val="F59E0B"/>
+          </a:solidFill>
+          <a:ln>
+            <a:noFill/>
+          </a:ln>
+          <a:effectLst/>
+        </p:spPr>
+        <p:style>
+          <a:lnRef idx="1">
+            <a:schemeClr val="accent1"/>
+          </a:lnRef>
+          <a:fillRef idx="3">
+            <a:schemeClr val="accent1"/>
+          </a:fillRef>
+          <a:effectRef idx="2">
+            <a:schemeClr val="accent1"/>
+          </a:effectRef>
+          <a:fontRef idx="minor">
+            <a:schemeClr val="lt1"/>
+          </a:fontRef>
+        </p:style>
+        <p:txBody>
+          <a:bodyPr rtlCol="0" anchor="ctr"/>
+          <a:lstStyle/>
+          <a:p>
+            <a:pPr algn="ctr"/>
+          </a:p>
+        </p:txBody>
+      </p:sp>
+      <p:sp>
+        <p:nvSpPr>
+          <p:cNvPr id="7" name="TextBox 6"/>
+          <p:cNvSpPr txBox="1"/>
+          <p:nvPr/>
+        </p:nvSpPr>
+        <p:spPr>
+          <a:xfrm>
+            <a:off x="502920" y="6419088"/>
+            <a:ext cx="7315200" cy="365760"/>
+          </a:xfrm>
+          <a:prstGeom prst="rect">
+            <a:avLst/>
+          </a:prstGeom>
+          <a:noFill/>
+        </p:spPr>
+        <p:txBody>
+          <a:bodyPr wrap="square" anchor="ctr" lIns="0" rIns="0" tIns="0" bIns="0">
+            <a:spAutoFit/>
+          </a:bodyPr>
+          <a:lstStyle/>
+          <a:p>
+            <a:pPr algn="l">
+              <a:lnSpc>
+                <a:spcPct val="100000"/>
+              </a:lnSpc>
+              <a:spcBef>
+                <a:spcPts val="0"/>
+              </a:spcBef>
+              <a:spcAft>
+                <a:spcPts val="600"/>
+              </a:spcAft>
+            </a:pPr>
+            <a:r>
+              <a:rPr sz="900" b="0">
+                <a:solidFill>
+                  <a:srgbClr val="64748B"/>
+                </a:solidFill>
+                <a:latin typeface="NanumGothic"/>
+                <a:ea typeface="NanumGothic"/>
+                <a:cs typeface="NanumGothic"/>
+              </a:rPr>
+              <a:t>AI 에이전트와 응용  ·  원광대학교 5일 교육</a:t>
+            </a:r>
+          </a:p>
+        </p:txBody>
+      </p:sp>
+      <p:sp>
+        <p:nvSpPr>
+          <p:cNvPr id="8" name="TextBox 7"/>
+          <p:cNvSpPr txBox="1"/>
+          <p:nvPr/>
+        </p:nvSpPr>
+        <p:spPr>
+          <a:xfrm>
+            <a:off x="10241280" y="6419088"/>
+            <a:ext cx="1463040" cy="365760"/>
+          </a:xfrm>
+          <a:prstGeom prst="rect">
+            <a:avLst/>
+          </a:prstGeom>
+          <a:noFill/>
+        </p:spPr>
+        <p:txBody>
+          <a:bodyPr wrap="square" anchor="ctr" lIns="0" rIns="0" tIns="0" bIns="0">
+            <a:spAutoFit/>
+          </a:bodyPr>
+          <a:lstStyle/>
+          <a:p>
+            <a:pPr algn="r">
+              <a:lnSpc>
+                <a:spcPct val="100000"/>
+              </a:lnSpc>
+              <a:spcBef>
+                <a:spcPts val="0"/>
+              </a:spcBef>
+              <a:spcAft>
+                <a:spcPts val="600"/>
+              </a:spcAft>
+            </a:pPr>
+            <a:r>
+              <a:rPr sz="900" b="1">
+                <a:solidFill>
+                  <a:srgbClr val="F59E0B"/>
+                </a:solidFill>
+                <a:latin typeface="NanumGothic"/>
+                <a:ea typeface="NanumGothic"/>
+                <a:cs typeface="NanumGothic"/>
+              </a:rPr>
+              <a:t>Day 4 · 목</a:t>
+            </a:r>
+          </a:p>
+        </p:txBody>
+      </p:sp>
+      <p:sp>
+        <p:nvSpPr>
+          <p:cNvPr id="9" name="Rounded Rectangle 8"/>
+          <p:cNvSpPr/>
+          <p:nvPr/>
+        </p:nvSpPr>
+        <p:spPr>
+          <a:xfrm>
+            <a:off x="502920" y="1783080"/>
+            <a:ext cx="7315200" cy="4160520"/>
+          </a:xfrm>
+          <a:prstGeom prst="roundRect">
+            <a:avLst/>
+          </a:prstGeom>
+          <a:solidFill>
+            <a:srgbClr val="F8FAFC"/>
+          </a:solidFill>
+          <a:ln w="12700">
+            <a:solidFill>
+              <a:srgbClr val="E2E8F0"/>
+            </a:solidFill>
+          </a:ln>
+          <a:effectLst/>
+        </p:spPr>
+        <p:style>
+          <a:lnRef idx="1">
+            <a:schemeClr val="accent1"/>
+          </a:lnRef>
+          <a:fillRef idx="3">
+            <a:schemeClr val="accent1"/>
+          </a:fillRef>
+          <a:effectRef idx="2">
+            <a:schemeClr val="accent1"/>
+          </a:effectRef>
+          <a:fontRef idx="minor">
+            <a:schemeClr val="lt1"/>
+          </a:fontRef>
+        </p:style>
+        <p:txBody>
+          <a:bodyPr rtlCol="0" anchor="ctr"/>
+          <a:lstStyle/>
+          <a:p>
+            <a:pPr algn="ctr"/>
+          </a:p>
+        </p:txBody>
+      </p:sp>
+      <p:sp>
+        <p:nvSpPr>
+          <p:cNvPr id="10" name="TextBox 9"/>
+          <p:cNvSpPr txBox="1"/>
+          <p:nvPr/>
+        </p:nvSpPr>
+        <p:spPr>
+          <a:xfrm>
+            <a:off x="777240" y="1965960"/>
+            <a:ext cx="6766560" cy="365760"/>
+          </a:xfrm>
+          <a:prstGeom prst="rect">
+            <a:avLst/>
+          </a:prstGeom>
+          <a:noFill/>
+        </p:spPr>
+        <p:txBody>
+          <a:bodyPr wrap="square" anchor="t" lIns="0" rIns="0" tIns="0" bIns="0">
+            <a:spAutoFit/>
+          </a:bodyPr>
+          <a:lstStyle/>
+          <a:p>
+            <a:pPr algn="l">
+              <a:lnSpc>
+                <a:spcPct val="100000"/>
+              </a:lnSpc>
+              <a:spcBef>
+                <a:spcPts val="0"/>
+              </a:spcBef>
+              <a:spcAft>
+                <a:spcPts val="600"/>
+              </a:spcAft>
+            </a:pPr>
+            <a:r>
+              <a:rPr sz="1300" b="1">
+                <a:solidFill>
+                  <a:srgbClr val="F59E0B"/>
+                </a:solidFill>
+                <a:latin typeface="NanumGothic"/>
+                <a:ea typeface="NanumGothic"/>
+                <a:cs typeface="NanumGothic"/>
+              </a:rPr>
+              <a:t>실습 단계</a:t>
+            </a:r>
+          </a:p>
+        </p:txBody>
+      </p:sp>
+      <p:sp>
+        <p:nvSpPr>
+          <p:cNvPr id="11" name="Oval 10"/>
+          <p:cNvSpPr/>
+          <p:nvPr/>
+        </p:nvSpPr>
+        <p:spPr>
+          <a:xfrm>
+            <a:off x="777240" y="2468880"/>
+            <a:ext cx="411480" cy="411480"/>
+          </a:xfrm>
+          <a:prstGeom prst="ellipse">
+            <a:avLst/>
+          </a:prstGeom>
+          <a:solidFill>
+            <a:srgbClr val="F59E0B"/>
+          </a:solidFill>
+          <a:ln>
+            <a:noFill/>
+          </a:ln>
+          <a:effectLst/>
+        </p:spPr>
+        <p:style>
+          <a:lnRef idx="1">
+            <a:schemeClr val="accent1"/>
+          </a:lnRef>
+          <a:fillRef idx="3">
+            <a:schemeClr val="accent1"/>
+          </a:fillRef>
+          <a:effectRef idx="2">
+            <a:schemeClr val="accent1"/>
+          </a:effectRef>
+          <a:fontRef idx="minor">
+            <a:schemeClr val="lt1"/>
+          </a:fontRef>
+        </p:style>
+        <p:txBody>
+          <a:bodyPr rtlCol="0" anchor="ctr"/>
+          <a:lstStyle/>
+          <a:p>
+            <a:pPr algn="ctr"/>
+          </a:p>
+        </p:txBody>
+      </p:sp>
+      <p:sp>
+        <p:nvSpPr>
+          <p:cNvPr id="12" name="TextBox 11"/>
+          <p:cNvSpPr txBox="1"/>
+          <p:nvPr/>
+        </p:nvSpPr>
+        <p:spPr>
+          <a:xfrm>
+            <a:off x="777240" y="2468880"/>
+            <a:ext cx="411480" cy="411480"/>
+          </a:xfrm>
+          <a:prstGeom prst="rect">
+            <a:avLst/>
+          </a:prstGeom>
+          <a:noFill/>
+        </p:spPr>
+        <p:txBody>
+          <a:bodyPr wrap="square" anchor="ctr" lIns="0" rIns="0" tIns="0" bIns="0">
+            <a:spAutoFit/>
+          </a:bodyPr>
+          <a:lstStyle/>
+          <a:p>
+            <a:pPr algn="ctr">
+              <a:lnSpc>
+                <a:spcPct val="100000"/>
+              </a:lnSpc>
+              <a:spcBef>
+                <a:spcPts val="0"/>
+              </a:spcBef>
+              <a:spcAft>
+                <a:spcPts val="600"/>
+              </a:spcAft>
+            </a:pPr>
+            <a:r>
+              <a:rPr sz="1300" b="1">
+                <a:solidFill>
+                  <a:srgbClr val="FFFFFF"/>
+                </a:solidFill>
+                <a:latin typeface="NanumSquare"/>
+                <a:ea typeface="NanumSquare"/>
+                <a:cs typeface="NanumSquare"/>
+              </a:rPr>
+              <a:t>1</a:t>
+            </a:r>
+          </a:p>
+        </p:txBody>
+      </p:sp>
+      <p:sp>
+        <p:nvSpPr>
+          <p:cNvPr id="13" name="TextBox 12"/>
+          <p:cNvSpPr txBox="1"/>
+          <p:nvPr/>
+        </p:nvSpPr>
+        <p:spPr>
+          <a:xfrm>
+            <a:off x="1371600" y="2487168"/>
+            <a:ext cx="6309360" cy="457200"/>
+          </a:xfrm>
+          <a:prstGeom prst="rect">
+            <a:avLst/>
+          </a:prstGeom>
+          <a:noFill/>
+        </p:spPr>
+        <p:txBody>
+          <a:bodyPr wrap="square" anchor="ctr" lIns="0" rIns="0" tIns="0" bIns="0">
+            <a:spAutoFit/>
+          </a:bodyPr>
+          <a:lstStyle/>
+          <a:p>
+            <a:pPr algn="l">
+              <a:lnSpc>
+                <a:spcPct val="100000"/>
+              </a:lnSpc>
+              <a:spcBef>
+                <a:spcPts val="0"/>
+              </a:spcBef>
+              <a:spcAft>
+                <a:spcPts val="600"/>
+              </a:spcAft>
+            </a:pPr>
+            <a:r>
+              <a:rPr sz="1400" b="0">
+                <a:solidFill>
+                  <a:srgbClr val="0F172A"/>
+                </a:solidFill>
+                <a:latin typeface="NanumGothic"/>
+                <a:ea typeface="NanumGothic"/>
+                <a:cs typeface="NanumGothic"/>
+              </a:rPr>
+              <a:t>gap에서 가설 다수 생성</a:t>
+            </a:r>
+          </a:p>
+        </p:txBody>
+      </p:sp>
+      <p:sp>
+        <p:nvSpPr>
+          <p:cNvPr id="14" name="Oval 13"/>
+          <p:cNvSpPr/>
+          <p:nvPr/>
+        </p:nvSpPr>
+        <p:spPr>
+          <a:xfrm>
+            <a:off x="777240" y="3035808"/>
+            <a:ext cx="411480" cy="411480"/>
+          </a:xfrm>
+          <a:prstGeom prst="ellipse">
+            <a:avLst/>
+          </a:prstGeom>
+          <a:solidFill>
+            <a:srgbClr val="F59E0B"/>
+          </a:solidFill>
+          <a:ln>
+            <a:noFill/>
+          </a:ln>
+          <a:effectLst/>
+        </p:spPr>
+        <p:style>
+          <a:lnRef idx="1">
+            <a:schemeClr val="accent1"/>
+          </a:lnRef>
+          <a:fillRef idx="3">
+            <a:schemeClr val="accent1"/>
+          </a:fillRef>
+          <a:effectRef idx="2">
+            <a:schemeClr val="accent1"/>
+          </a:effectRef>
+          <a:fontRef idx="minor">
+            <a:schemeClr val="lt1"/>
+          </a:fontRef>
+        </p:style>
+        <p:txBody>
+          <a:bodyPr rtlCol="0" anchor="ctr"/>
+          <a:lstStyle/>
+          <a:p>
+            <a:pPr algn="ctr"/>
+          </a:p>
+        </p:txBody>
+      </p:sp>
+      <p:sp>
+        <p:nvSpPr>
+          <p:cNvPr id="15" name="TextBox 14"/>
+          <p:cNvSpPr txBox="1"/>
+          <p:nvPr/>
+        </p:nvSpPr>
+        <p:spPr>
+          <a:xfrm>
+            <a:off x="777240" y="3035808"/>
+            <a:ext cx="411480" cy="411480"/>
+          </a:xfrm>
+          <a:prstGeom prst="rect">
+            <a:avLst/>
+          </a:prstGeom>
+          <a:noFill/>
+        </p:spPr>
+        <p:txBody>
+          <a:bodyPr wrap="square" anchor="ctr" lIns="0" rIns="0" tIns="0" bIns="0">
+            <a:spAutoFit/>
+          </a:bodyPr>
+          <a:lstStyle/>
+          <a:p>
+            <a:pPr algn="ctr">
+              <a:lnSpc>
+                <a:spcPct val="100000"/>
+              </a:lnSpc>
+              <a:spcBef>
+                <a:spcPts val="0"/>
+              </a:spcBef>
+              <a:spcAft>
+                <a:spcPts val="600"/>
+              </a:spcAft>
+            </a:pPr>
+            <a:r>
+              <a:rPr sz="1300" b="1">
+                <a:solidFill>
+                  <a:srgbClr val="FFFFFF"/>
+                </a:solidFill>
+                <a:latin typeface="NanumSquare"/>
+                <a:ea typeface="NanumSquare"/>
+                <a:cs typeface="NanumSquare"/>
+              </a:rPr>
+              <a:t>2</a:t>
+            </a:r>
+          </a:p>
+        </p:txBody>
+      </p:sp>
+      <p:sp>
+        <p:nvSpPr>
+          <p:cNvPr id="16" name="TextBox 15"/>
+          <p:cNvSpPr txBox="1"/>
+          <p:nvPr/>
+        </p:nvSpPr>
+        <p:spPr>
+          <a:xfrm>
+            <a:off x="1371600" y="3054096"/>
+            <a:ext cx="6309360" cy="457200"/>
+          </a:xfrm>
+          <a:prstGeom prst="rect">
+            <a:avLst/>
+          </a:prstGeom>
+          <a:noFill/>
+        </p:spPr>
+        <p:txBody>
+          <a:bodyPr wrap="square" anchor="ctr" lIns="0" rIns="0" tIns="0" bIns="0">
+            <a:spAutoFit/>
+          </a:bodyPr>
+          <a:lstStyle/>
+          <a:p>
+            <a:pPr algn="l">
+              <a:lnSpc>
+                <a:spcPct val="100000"/>
+              </a:lnSpc>
+              <a:spcBef>
+                <a:spcPts val="0"/>
+              </a:spcBef>
+              <a:spcAft>
+                <a:spcPts val="600"/>
+              </a:spcAft>
+            </a:pPr>
+            <a:r>
+              <a:rPr sz="1400" b="0">
+                <a:solidFill>
+                  <a:srgbClr val="0F172A"/>
+                </a:solidFill>
+                <a:latin typeface="NanumGothic"/>
+                <a:ea typeface="NanumGothic"/>
+                <a:cs typeface="NanumGothic"/>
+              </a:rPr>
+              <a:t>기준별 평가·점수·랭킹</a:t>
+            </a:r>
+          </a:p>
+        </p:txBody>
+      </p:sp>
+      <p:sp>
+        <p:nvSpPr>
+          <p:cNvPr id="17" name="Oval 16"/>
+          <p:cNvSpPr/>
+          <p:nvPr/>
+        </p:nvSpPr>
+        <p:spPr>
+          <a:xfrm>
+            <a:off x="777240" y="3602736"/>
+            <a:ext cx="411480" cy="411480"/>
+          </a:xfrm>
+          <a:prstGeom prst="ellipse">
+            <a:avLst/>
+          </a:prstGeom>
+          <a:solidFill>
+            <a:srgbClr val="F59E0B"/>
+          </a:solidFill>
+          <a:ln>
+            <a:noFill/>
+          </a:ln>
+          <a:effectLst/>
+        </p:spPr>
+        <p:style>
+          <a:lnRef idx="1">
+            <a:schemeClr val="accent1"/>
+          </a:lnRef>
+          <a:fillRef idx="3">
+            <a:schemeClr val="accent1"/>
+          </a:fillRef>
+          <a:effectRef idx="2">
+            <a:schemeClr val="accent1"/>
+          </a:effectRef>
+          <a:fontRef idx="minor">
+            <a:schemeClr val="lt1"/>
+          </a:fontRef>
+        </p:style>
+        <p:txBody>
+          <a:bodyPr rtlCol="0" anchor="ctr"/>
+          <a:lstStyle/>
+          <a:p>
+            <a:pPr algn="ctr"/>
+          </a:p>
+        </p:txBody>
+      </p:sp>
+      <p:sp>
+        <p:nvSpPr>
+          <p:cNvPr id="18" name="TextBox 17"/>
+          <p:cNvSpPr txBox="1"/>
+          <p:nvPr/>
+        </p:nvSpPr>
+        <p:spPr>
+          <a:xfrm>
+            <a:off x="777240" y="3602736"/>
+            <a:ext cx="411480" cy="411480"/>
+          </a:xfrm>
+          <a:prstGeom prst="rect">
+            <a:avLst/>
+          </a:prstGeom>
+          <a:noFill/>
+        </p:spPr>
+        <p:txBody>
+          <a:bodyPr wrap="square" anchor="ctr" lIns="0" rIns="0" tIns="0" bIns="0">
+            <a:spAutoFit/>
+          </a:bodyPr>
+          <a:lstStyle/>
+          <a:p>
+            <a:pPr algn="ctr">
+              <a:lnSpc>
+                <a:spcPct val="100000"/>
+              </a:lnSpc>
+              <a:spcBef>
+                <a:spcPts val="0"/>
+              </a:spcBef>
+              <a:spcAft>
+                <a:spcPts val="600"/>
+              </a:spcAft>
+            </a:pPr>
+            <a:r>
+              <a:rPr sz="1300" b="1">
+                <a:solidFill>
+                  <a:srgbClr val="FFFFFF"/>
+                </a:solidFill>
+                <a:latin typeface="NanumSquare"/>
+                <a:ea typeface="NanumSquare"/>
+                <a:cs typeface="NanumSquare"/>
+              </a:rPr>
+              <a:t>3</a:t>
+            </a:r>
+          </a:p>
+        </p:txBody>
+      </p:sp>
+      <p:sp>
+        <p:nvSpPr>
+          <p:cNvPr id="19" name="TextBox 18"/>
+          <p:cNvSpPr txBox="1"/>
+          <p:nvPr/>
+        </p:nvSpPr>
+        <p:spPr>
+          <a:xfrm>
+            <a:off x="1371600" y="3621024"/>
+            <a:ext cx="6309360" cy="457200"/>
+          </a:xfrm>
+          <a:prstGeom prst="rect">
+            <a:avLst/>
+          </a:prstGeom>
+          <a:noFill/>
+        </p:spPr>
+        <p:txBody>
+          <a:bodyPr wrap="square" anchor="ctr" lIns="0" rIns="0" tIns="0" bIns="0">
+            <a:spAutoFit/>
+          </a:bodyPr>
+          <a:lstStyle/>
+          <a:p>
+            <a:pPr algn="l">
+              <a:lnSpc>
+                <a:spcPct val="100000"/>
+              </a:lnSpc>
+              <a:spcBef>
+                <a:spcPts val="0"/>
+              </a:spcBef>
+              <a:spcAft>
+                <a:spcPts val="600"/>
+              </a:spcAft>
+            </a:pPr>
+            <a:r>
+              <a:rPr sz="1400" b="0">
+                <a:solidFill>
+                  <a:srgbClr val="0F172A"/>
+                </a:solidFill>
+                <a:latin typeface="NanumGothic"/>
+                <a:ea typeface="NanumGothic"/>
+                <a:cs typeface="NanumGothic"/>
+              </a:rPr>
+              <a:t>우선순위 1~2개 + rationale 보강</a:t>
+            </a:r>
+          </a:p>
+        </p:txBody>
+      </p:sp>
+      <p:sp>
+        <p:nvSpPr>
+          <p:cNvPr id="20" name="Oval 19"/>
+          <p:cNvSpPr/>
+          <p:nvPr/>
+        </p:nvSpPr>
+        <p:spPr>
+          <a:xfrm>
+            <a:off x="777240" y="4169664"/>
+            <a:ext cx="411480" cy="411480"/>
+          </a:xfrm>
+          <a:prstGeom prst="ellipse">
+            <a:avLst/>
+          </a:prstGeom>
+          <a:solidFill>
+            <a:srgbClr val="F59E0B"/>
+          </a:solidFill>
+          <a:ln>
+            <a:noFill/>
+          </a:ln>
+          <a:effectLst/>
+        </p:spPr>
+        <p:style>
+          <a:lnRef idx="1">
+            <a:schemeClr val="accent1"/>
+          </a:lnRef>
+          <a:fillRef idx="3">
+            <a:schemeClr val="accent1"/>
+          </a:fillRef>
+          <a:effectRef idx="2">
+            <a:schemeClr val="accent1"/>
+          </a:effectRef>
+          <a:fontRef idx="minor">
+            <a:schemeClr val="lt1"/>
+          </a:fontRef>
+        </p:style>
+        <p:txBody>
+          <a:bodyPr rtlCol="0" anchor="ctr"/>
+          <a:lstStyle/>
+          <a:p>
+            <a:pPr algn="ctr"/>
+          </a:p>
+        </p:txBody>
+      </p:sp>
+      <p:sp>
+        <p:nvSpPr>
+          <p:cNvPr id="21" name="TextBox 20"/>
+          <p:cNvSpPr txBox="1"/>
+          <p:nvPr/>
+        </p:nvSpPr>
+        <p:spPr>
+          <a:xfrm>
+            <a:off x="777240" y="4169664"/>
+            <a:ext cx="411480" cy="411480"/>
+          </a:xfrm>
+          <a:prstGeom prst="rect">
+            <a:avLst/>
+          </a:prstGeom>
+          <a:noFill/>
+        </p:spPr>
+        <p:txBody>
+          <a:bodyPr wrap="square" anchor="ctr" lIns="0" rIns="0" tIns="0" bIns="0">
+            <a:spAutoFit/>
+          </a:bodyPr>
+          <a:lstStyle/>
+          <a:p>
+            <a:pPr algn="ctr">
+              <a:lnSpc>
+                <a:spcPct val="100000"/>
+              </a:lnSpc>
+              <a:spcBef>
+                <a:spcPts val="0"/>
+              </a:spcBef>
+              <a:spcAft>
+                <a:spcPts val="600"/>
+              </a:spcAft>
+            </a:pPr>
+            <a:r>
+              <a:rPr sz="1300" b="1">
+                <a:solidFill>
+                  <a:srgbClr val="FFFFFF"/>
+                </a:solidFill>
+                <a:latin typeface="NanumSquare"/>
+                <a:ea typeface="NanumSquare"/>
+                <a:cs typeface="NanumSquare"/>
+              </a:rPr>
+              <a:t>4</a:t>
+            </a:r>
+          </a:p>
+        </p:txBody>
+      </p:sp>
+      <p:sp>
+        <p:nvSpPr>
+          <p:cNvPr id="22" name="TextBox 21"/>
+          <p:cNvSpPr txBox="1"/>
+          <p:nvPr/>
+        </p:nvSpPr>
+        <p:spPr>
+          <a:xfrm>
+            <a:off x="1371600" y="4187952"/>
+            <a:ext cx="6309360" cy="457200"/>
+          </a:xfrm>
+          <a:prstGeom prst="rect">
+            <a:avLst/>
+          </a:prstGeom>
+          <a:noFill/>
+        </p:spPr>
+        <p:txBody>
+          <a:bodyPr wrap="square" anchor="ctr" lIns="0" rIns="0" tIns="0" bIns="0">
+            <a:spAutoFit/>
+          </a:bodyPr>
+          <a:lstStyle/>
+          <a:p>
+            <a:pPr algn="l">
+              <a:lnSpc>
+                <a:spcPct val="100000"/>
+              </a:lnSpc>
+              <a:spcBef>
+                <a:spcPts val="0"/>
+              </a:spcBef>
+              <a:spcAft>
+                <a:spcPts val="600"/>
+              </a:spcAft>
+            </a:pPr>
+            <a:r>
+              <a:rPr sz="1400" b="0">
+                <a:solidFill>
+                  <a:srgbClr val="0F172A"/>
+                </a:solidFill>
+                <a:latin typeface="NanumGothic"/>
+                <a:ea typeface="NanumGothic"/>
+                <a:cs typeface="NanumGothic"/>
+              </a:rPr>
+              <a:t>가설 제안 확정</a:t>
+            </a:r>
+          </a:p>
+        </p:txBody>
+      </p:sp>
+      <p:sp>
+        <p:nvSpPr>
+          <p:cNvPr id="23" name="Rounded Rectangle 22"/>
+          <p:cNvSpPr/>
+          <p:nvPr/>
+        </p:nvSpPr>
+        <p:spPr>
+          <a:xfrm>
+            <a:off x="8001000" y="1783080"/>
+            <a:ext cx="3657600" cy="4160520"/>
+          </a:xfrm>
+          <a:prstGeom prst="roundRect">
+            <a:avLst/>
+          </a:prstGeom>
+          <a:solidFill>
+            <a:srgbClr val="12203C"/>
+          </a:solidFill>
+          <a:ln>
+            <a:noFill/>
+          </a:ln>
+          <a:effectLst/>
+        </p:spPr>
+        <p:style>
+          <a:lnRef idx="1">
+            <a:schemeClr val="accent1"/>
+          </a:lnRef>
+          <a:fillRef idx="3">
+            <a:schemeClr val="accent1"/>
+          </a:fillRef>
+          <a:effectRef idx="2">
+            <a:schemeClr val="accent1"/>
+          </a:effectRef>
+          <a:fontRef idx="minor">
+            <a:schemeClr val="lt1"/>
+          </a:fontRef>
+        </p:style>
+        <p:txBody>
+          <a:bodyPr rtlCol="0" anchor="ctr"/>
+          <a:lstStyle/>
+          <a:p>
+            <a:pPr algn="ctr"/>
+          </a:p>
+        </p:txBody>
+      </p:sp>
+      <p:sp>
+        <p:nvSpPr>
+          <p:cNvPr id="24" name="TextBox 23"/>
+          <p:cNvSpPr txBox="1"/>
+          <p:nvPr/>
+        </p:nvSpPr>
+        <p:spPr>
+          <a:xfrm>
+            <a:off x="8275320" y="2011680"/>
+            <a:ext cx="3108960" cy="457200"/>
+          </a:xfrm>
+          <a:prstGeom prst="rect">
+            <a:avLst/>
+          </a:prstGeom>
+          <a:noFill/>
+        </p:spPr>
+        <p:txBody>
+          <a:bodyPr wrap="square" anchor="t" lIns="0" rIns="0" tIns="0" bIns="0">
+            <a:spAutoFit/>
+          </a:bodyPr>
+          <a:lstStyle/>
+          <a:p>
+            <a:pPr algn="l">
+              <a:lnSpc>
+                <a:spcPct val="100000"/>
+              </a:lnSpc>
+              <a:spcBef>
+                <a:spcPts val="0"/>
+              </a:spcBef>
+              <a:spcAft>
+                <a:spcPts val="600"/>
+              </a:spcAft>
+            </a:pPr>
+            <a:r>
+              <a:rPr sz="1500" b="1">
+                <a:solidFill>
+                  <a:srgbClr val="F59E0B"/>
+                </a:solidFill>
+                <a:latin typeface="NanumSquare"/>
+                <a:ea typeface="NanumSquare"/>
+                <a:cs typeface="NanumSquare"/>
+              </a:rPr>
+              <a:t>산출물</a:t>
+            </a:r>
+          </a:p>
+        </p:txBody>
+      </p:sp>
+      <p:sp>
+        <p:nvSpPr>
+          <p:cNvPr id="25" name="TextBox 24"/>
+          <p:cNvSpPr txBox="1"/>
+          <p:nvPr/>
+        </p:nvSpPr>
+        <p:spPr>
+          <a:xfrm>
+            <a:off x="8275320" y="2560320"/>
+            <a:ext cx="3154680" cy="3108960"/>
+          </a:xfrm>
+          <a:prstGeom prst="rect">
+            <a:avLst/>
+          </a:prstGeom>
+          <a:noFill/>
+        </p:spPr>
+        <p:txBody>
+          <a:bodyPr wrap="square" anchor="t" lIns="0" rIns="0" tIns="0" bIns="0">
+            <a:spAutoFit/>
+          </a:bodyPr>
+          <a:lstStyle/>
+          <a:p>
+            <a:pPr algn="l">
+              <a:lnSpc>
+                <a:spcPct val="120000"/>
+              </a:lnSpc>
+              <a:spcBef>
+                <a:spcPts val="0"/>
+              </a:spcBef>
+              <a:spcAft>
+                <a:spcPts val="600"/>
+              </a:spcAft>
+            </a:pPr>
+            <a:r>
+              <a:rPr sz="1400" b="0">
+                <a:solidFill>
+                  <a:srgbClr val="FFFFFF"/>
+                </a:solidFill>
+                <a:latin typeface="NanumGothic"/>
+                <a:ea typeface="NanumGothic"/>
+                <a:cs typeface="NanumGothic"/>
+              </a:rPr>
+              <a:t>최종 가설 제안 + 분석 노트
+에이전트 완주! 양식: output/report-template.md · 분석: result-analysis-template.md</a:t>
+            </a:r>
+          </a:p>
+        </p:txBody>
+      </p:sp>
+    </p:spTree>
+  </p:cSld>
+  <p:clrMapOvr>
+    <a:masterClrMapping/>
+  </p:clrMapOvr>
+</p:sld>
+</file>
+
+<file path=ppt/slides/slide26.xml><?xml version="1.0" encoding="utf-8"?>
 <p:sld xmlns:a="http://schemas.openxmlformats.org/drawingml/2006/main" xmlns:p="http://schemas.openxmlformats.org/presentationml/2006/main" xmlns:r="http://schemas.openxmlformats.org/officeDocument/2006/relationships">
   <p:cSld>
     <p:spTree>

</xml_diff>

<commit_message>
Split topics into per-part slides + NOTE convention (examples→body)
- Day 1: split 정렬(SFT/보상모델/강화학습), RAG(질문/검색/주입/생성), 프롬프트 기법(역할/few-shot/CoT) → one slide per part (31→42)
- Day 2: split 핵심 루프(관찰/사고/행동/반복), 바이브코딩 사이클(의도/생성/실행/검증) (35→43)
- NOTE convention: move all 예시·사례 from NOTE into body bullets; NOTE now 요약/주의/연결 only (18 slides retrofitted)
- Day 2 과학·신약 slide: + Deep Research bullet (research agents)

Co-Authored-By: Claude Opus 4.8 <noreply@anthropic.com>
</commit_message>
<xml_diff>
--- a/slides/day4.pptx
+++ b/slides/day4.pptx
@@ -7866,7 +7866,145 @@
       </p:sp>
       <p:sp>
         <p:nvSpPr>
-          <p:cNvPr id="18" name="Rounded Rectangle 17"/>
+          <p:cNvPr id="18" name="Oval 17"/>
+          <p:cNvSpPr/>
+          <p:nvPr/>
+        </p:nvSpPr>
+        <p:spPr>
+          <a:xfrm>
+            <a:off x="548640" y="4517136"/>
+            <a:ext cx="146304" cy="146304"/>
+          </a:xfrm>
+          <a:prstGeom prst="ellipse">
+            <a:avLst/>
+          </a:prstGeom>
+          <a:solidFill>
+            <a:srgbClr val="F59E0B"/>
+          </a:solidFill>
+          <a:ln>
+            <a:noFill/>
+          </a:ln>
+          <a:effectLst/>
+        </p:spPr>
+        <p:style>
+          <a:lnRef idx="1">
+            <a:schemeClr val="accent1"/>
+          </a:lnRef>
+          <a:fillRef idx="3">
+            <a:schemeClr val="accent1"/>
+          </a:fillRef>
+          <a:effectRef idx="2">
+            <a:schemeClr val="accent1"/>
+          </a:effectRef>
+          <a:fontRef idx="minor">
+            <a:schemeClr val="lt1"/>
+          </a:fontRef>
+        </p:style>
+        <p:txBody>
+          <a:bodyPr rtlCol="0" anchor="ctr"/>
+          <a:lstStyle/>
+          <a:p>
+            <a:pPr algn="ctr"/>
+          </a:p>
+        </p:txBody>
+      </p:sp>
+      <p:sp>
+        <p:nvSpPr>
+          <p:cNvPr id="19" name="TextBox 18"/>
+          <p:cNvSpPr txBox="1"/>
+          <p:nvPr/>
+        </p:nvSpPr>
+        <p:spPr>
+          <a:xfrm>
+            <a:off x="868680" y="4434840"/>
+            <a:ext cx="10607040" cy="457200"/>
+          </a:xfrm>
+          <a:prstGeom prst="rect">
+            <a:avLst/>
+          </a:prstGeom>
+          <a:noFill/>
+        </p:spPr>
+        <p:txBody>
+          <a:bodyPr wrap="square" anchor="t" lIns="0" rIns="0" tIns="0" bIns="0">
+            <a:spAutoFit/>
+          </a:bodyPr>
+          <a:lstStyle/>
+          <a:p>
+            <a:pPr algn="l">
+              <a:lnSpc>
+                <a:spcPct val="100000"/>
+              </a:lnSpc>
+              <a:spcBef>
+                <a:spcPts val="0"/>
+              </a:spcBef>
+              <a:spcAft>
+                <a:spcPts val="600"/>
+              </a:spcAft>
+            </a:pPr>
+            <a:r>
+              <a:rPr sz="1600" b="1">
+                <a:solidFill>
+                  <a:srgbClr val="0F172A"/>
+                </a:solidFill>
+                <a:latin typeface="NanumGothic"/>
+                <a:ea typeface="NanumGothic"/>
+                <a:cs typeface="NanumGothic"/>
+              </a:rPr>
+              <a:t>예시</a:t>
+            </a:r>
+          </a:p>
+        </p:txBody>
+      </p:sp>
+      <p:sp>
+        <p:nvSpPr>
+          <p:cNvPr id="20" name="TextBox 19"/>
+          <p:cNvSpPr txBox="1"/>
+          <p:nvPr/>
+        </p:nvSpPr>
+        <p:spPr>
+          <a:xfrm>
+            <a:off x="868680" y="4818888"/>
+            <a:ext cx="10607040" cy="457200"/>
+          </a:xfrm>
+          <a:prstGeom prst="rect">
+            <a:avLst/>
+          </a:prstGeom>
+          <a:noFill/>
+        </p:spPr>
+        <p:txBody>
+          <a:bodyPr wrap="square" anchor="t" lIns="0" rIns="0" tIns="0" bIns="0">
+            <a:spAutoFit/>
+          </a:bodyPr>
+          <a:lstStyle/>
+          <a:p>
+            <a:pPr algn="l">
+              <a:lnSpc>
+                <a:spcPct val="100000"/>
+              </a:lnSpc>
+              <a:spcBef>
+                <a:spcPts val="0"/>
+              </a:spcBef>
+              <a:spcAft>
+                <a:spcPts val="600"/>
+              </a:spcAft>
+            </a:pPr>
+            <a:r>
+              <a:rPr sz="1300" b="0">
+                <a:solidFill>
+                  <a:srgbClr val="64748B"/>
+                </a:solidFill>
+                <a:latin typeface="NanumGothic"/>
+                <a:ea typeface="NanumGothic"/>
+                <a:cs typeface="NanumGothic"/>
+              </a:rPr>
+              <a:t>논문마다 동일 표로 → 주장이 엇갈리는 행이 한눈에</a:t>
+            </a:r>
+          </a:p>
+        </p:txBody>
+      </p:sp>
+      <p:sp>
+        <p:nvSpPr>
+          <p:cNvPr id="21" name="Rounded Rectangle 20"/>
           <p:cNvSpPr/>
           <p:nvPr/>
         </p:nvSpPr>
@@ -7912,7 +8050,7 @@
       </p:sp>
       <p:sp>
         <p:nvSpPr>
-          <p:cNvPr id="19" name="TextBox 18"/>
+          <p:cNvPr id="22" name="TextBox 21"/>
           <p:cNvSpPr txBox="1"/>
           <p:nvPr/>
         </p:nvSpPr>
@@ -7963,7 +8101,7 @@
                 <a:ea typeface="NanumGothic"/>
                 <a:cs typeface="NanumGothic"/>
               </a:rPr>
-              <a:t>예: 논문마다 동일 표로 → 주장이 엇갈리는 행이 한눈에</a:t>
+              <a:t>정규화해야 비교가 되고, 비교에서 gap이 드러난다</a:t>
             </a:r>
           </a:p>
         </p:txBody>
@@ -16706,7 +16844,145 @@
       </p:sp>
       <p:sp>
         <p:nvSpPr>
-          <p:cNvPr id="18" name="Rounded Rectangle 17"/>
+          <p:cNvPr id="18" name="Oval 17"/>
+          <p:cNvSpPr/>
+          <p:nvPr/>
+        </p:nvSpPr>
+        <p:spPr>
+          <a:xfrm>
+            <a:off x="548640" y="4517136"/>
+            <a:ext cx="146304" cy="146304"/>
+          </a:xfrm>
+          <a:prstGeom prst="ellipse">
+            <a:avLst/>
+          </a:prstGeom>
+          <a:solidFill>
+            <a:srgbClr val="F59E0B"/>
+          </a:solidFill>
+          <a:ln>
+            <a:noFill/>
+          </a:ln>
+          <a:effectLst/>
+        </p:spPr>
+        <p:style>
+          <a:lnRef idx="1">
+            <a:schemeClr val="accent1"/>
+          </a:lnRef>
+          <a:fillRef idx="3">
+            <a:schemeClr val="accent1"/>
+          </a:fillRef>
+          <a:effectRef idx="2">
+            <a:schemeClr val="accent1"/>
+          </a:effectRef>
+          <a:fontRef idx="minor">
+            <a:schemeClr val="lt1"/>
+          </a:fontRef>
+        </p:style>
+        <p:txBody>
+          <a:bodyPr rtlCol="0" anchor="ctr"/>
+          <a:lstStyle/>
+          <a:p>
+            <a:pPr algn="ctr"/>
+          </a:p>
+        </p:txBody>
+      </p:sp>
+      <p:sp>
+        <p:nvSpPr>
+          <p:cNvPr id="19" name="TextBox 18"/>
+          <p:cNvSpPr txBox="1"/>
+          <p:nvPr/>
+        </p:nvSpPr>
+        <p:spPr>
+          <a:xfrm>
+            <a:off x="868680" y="4434840"/>
+            <a:ext cx="10607040" cy="457200"/>
+          </a:xfrm>
+          <a:prstGeom prst="rect">
+            <a:avLst/>
+          </a:prstGeom>
+          <a:noFill/>
+        </p:spPr>
+        <p:txBody>
+          <a:bodyPr wrap="square" anchor="t" lIns="0" rIns="0" tIns="0" bIns="0">
+            <a:spAutoFit/>
+          </a:bodyPr>
+          <a:lstStyle/>
+          <a:p>
+            <a:pPr algn="l">
+              <a:lnSpc>
+                <a:spcPct val="100000"/>
+              </a:lnSpc>
+              <a:spcBef>
+                <a:spcPts val="0"/>
+              </a:spcBef>
+              <a:spcAft>
+                <a:spcPts val="600"/>
+              </a:spcAft>
+            </a:pPr>
+            <a:r>
+              <a:rPr sz="1600" b="1">
+                <a:solidFill>
+                  <a:srgbClr val="0F172A"/>
+                </a:solidFill>
+                <a:latin typeface="NanumGothic"/>
+                <a:ea typeface="NanumGothic"/>
+                <a:cs typeface="NanumGothic"/>
+              </a:rPr>
+              <a:t>예시</a:t>
+            </a:r>
+          </a:p>
+        </p:txBody>
+      </p:sp>
+      <p:sp>
+        <p:nvSpPr>
+          <p:cNvPr id="20" name="TextBox 19"/>
+          <p:cNvSpPr txBox="1"/>
+          <p:nvPr/>
+        </p:nvSpPr>
+        <p:spPr>
+          <a:xfrm>
+            <a:off x="868680" y="4818888"/>
+            <a:ext cx="10607040" cy="457200"/>
+          </a:xfrm>
+          <a:prstGeom prst="rect">
+            <a:avLst/>
+          </a:prstGeom>
+          <a:noFill/>
+        </p:spPr>
+        <p:txBody>
+          <a:bodyPr wrap="square" anchor="t" lIns="0" rIns="0" tIns="0" bIns="0">
+            <a:spAutoFit/>
+          </a:bodyPr>
+          <a:lstStyle/>
+          <a:p>
+            <a:pPr algn="l">
+              <a:lnSpc>
+                <a:spcPct val="100000"/>
+              </a:lnSpc>
+              <a:spcBef>
+                <a:spcPts val="0"/>
+              </a:spcBef>
+              <a:spcAft>
+                <a:spcPts val="600"/>
+              </a:spcAft>
+            </a:pPr>
+            <a:r>
+              <a:rPr sz="1300" b="0">
+                <a:solidFill>
+                  <a:srgbClr val="64748B"/>
+                </a:solidFill>
+                <a:latin typeface="NanumGothic"/>
+                <a:ea typeface="NanumGothic"/>
+                <a:cs typeface="NanumGothic"/>
+              </a:rPr>
+              <a:t>'단시간 수면자는 특정 유전형에서 인지저하가 덜할 것이다'</a:t>
+            </a:r>
+          </a:p>
+        </p:txBody>
+      </p:sp>
+      <p:sp>
+        <p:nvSpPr>
+          <p:cNvPr id="21" name="Rounded Rectangle 20"/>
           <p:cNvSpPr/>
           <p:nvPr/>
         </p:nvSpPr>
@@ -16752,7 +17028,7 @@
       </p:sp>
       <p:sp>
         <p:nvSpPr>
-          <p:cNvPr id="19" name="TextBox 18"/>
+          <p:cNvPr id="22" name="TextBox 21"/>
           <p:cNvSpPr txBox="1"/>
           <p:nvPr/>
         </p:nvSpPr>
@@ -16803,7 +17079,7 @@
                 <a:ea typeface="NanumGothic"/>
                 <a:cs typeface="NanumGothic"/>
               </a:rPr>
-              <a:t>예: '단시간 수면자는 특정 유전형에서 인지저하가 덜할 것이다'</a:t>
+              <a:t>많이·다양하게가 이 단계의 목표</a:t>
             </a:r>
           </a:p>
         </p:txBody>

</xml_diff>

<commit_message>
Add intermediate research worksheets (literature matrix, gap list, hypothesis eval)
Fill the pipeline gap between agent rules and final proposal:
- worksheets/1-literature-matrix (자료 파악, 단계③ schema)
- worksheets/2-gap-list (gap 발견, 유형·근거)
- worksheets/3-hypothesis-eval (가설 생성·평가, 단계④⑤ scoring)
Each with a filled example. Wired into Day 4 lab deliverables + research-agent README.

Co-Authored-By: Claude Opus 4.8 <noreply@anthropic.com>
</commit_message>
<xml_diff>
--- a/slides/day4.pptx
+++ b/slides/day4.pptx
@@ -12389,8 +12389,8 @@
                 <a:ea typeface="NanumGothic"/>
                 <a:cs typeface="NanumGothic"/>
               </a:rPr>
-              <a:t>자료 지도 + gap 목록 (근거 포함)
-규칙: examples/research-agent/CLAUDE.md</a:t>
+              <a:t>논문 정리표 + gap 목록 (근거 포함)
+시트: worksheets/1-literature-matrix · 2-gap-list</a:t>
             </a:r>
           </a:p>
         </p:txBody>
@@ -23961,8 +23961,8 @@
                 <a:ea typeface="NanumGothic"/>
                 <a:cs typeface="NanumGothic"/>
               </a:rPr>
-              <a:t>최종 가설 제안 + 분석 노트
-에이전트 완주! 양식: output/report-template.md · 분석: result-analysis-template.md</a:t>
+              <a:t>가설 평가표 → 최종 가설 제안
+시트: worksheets/3-hypothesis-eval · 제안서: output/report-template.md</a:t>
             </a:r>
           </a:p>
         </p:txBody>

</xml_diff>